<commit_message>
feat: add high-level pro features to presentation and brief
Elevated the technical depth and professional look of the instructional
materials:
- Updated `generate_full_course_presentation.py` to include Speaker
  Notes on every slide to guide the trainer's discourse.
- Added deep dive slides on Normalization (1NF to BCNF), Performance
  (B-Tree Indexes, EXPLAIN), and Advanced SQL (CTEs, Window Functions).
- Updated `generate_instructor_brief.py` to include an Advanced
  Architecture masterclass section for the trainer.
- Regenerated the `.pptx` and `.docx` binary files.

Co-authored-by: ArthurStarks <137041166+ArthurStarks@users.noreply.github.com>
</commit_message>
<xml_diff>
--- a/Cours_Complet_BDD_et_SQL.pptx
+++ b/Cours_Complet_BDD_et_SQL.pptx
@@ -6,17 +6,20 @@
   </p:sldMasterIdLst>
   <p:sldIdLst>
     <p:sldId id="256" r:id="rId7"/>
-    <p:sldId id="257" r:id="rId8"/>
-    <p:sldId id="258" r:id="rId9"/>
-    <p:sldId id="259" r:id="rId10"/>
-    <p:sldId id="260" r:id="rId11"/>
-    <p:sldId id="261" r:id="rId12"/>
-    <p:sldId id="262" r:id="rId13"/>
-    <p:sldId id="263" r:id="rId14"/>
-    <p:sldId id="264" r:id="rId15"/>
-    <p:sldId id="265" r:id="rId16"/>
-    <p:sldId id="266" r:id="rId17"/>
-    <p:sldId id="267" r:id="rId18"/>
+    <p:sldId id="257" r:id="rId9"/>
+    <p:sldId id="258" r:id="rId10"/>
+    <p:sldId id="259" r:id="rId11"/>
+    <p:sldId id="260" r:id="rId12"/>
+    <p:sldId id="261" r:id="rId13"/>
+    <p:sldId id="262" r:id="rId14"/>
+    <p:sldId id="263" r:id="rId15"/>
+    <p:sldId id="264" r:id="rId16"/>
+    <p:sldId id="265" r:id="rId17"/>
+    <p:sldId id="266" r:id="rId18"/>
+    <p:sldId id="267" r:id="rId19"/>
+    <p:sldId id="268" r:id="rId20"/>
+    <p:sldId id="269" r:id="rId21"/>
+    <p:sldId id="270" r:id="rId22"/>
   </p:sldIdLst>
   <p:sldSz cx="9144000" cy="6858000" type="screen4x3"/>
   <p:notesSz cx="6858000" cy="9144000"/>
@@ -116,6 +119,986 @@
     </a:lvl9pPr>
   </p:defaultTextStyle>
 </p:presentation>
+</file>
+
+<file path=ppt/notesMasters/notesMaster1.xml><?xml version="1.0" encoding="utf-8"?>
+<p:notesMaster xmlns:a="http://schemas.openxmlformats.org/drawingml/2006/main" xmlns:p="http://schemas.openxmlformats.org/presentationml/2006/main" xmlns:r="http://schemas.openxmlformats.org/officeDocument/2006/relationships">
+  <p:cSld>
+    <p:bg>
+      <p:bgRef idx="1001">
+        <a:schemeClr val="bg1"/>
+      </p:bgRef>
+    </p:bg>
+    <p:spTree>
+      <p:nvGrpSpPr>
+        <p:cNvPr id="1" name=""/>
+        <p:cNvGrpSpPr/>
+        <p:nvPr/>
+      </p:nvGrpSpPr>
+      <p:grpSpPr>
+        <a:xfrm>
+          <a:off x="0" y="0"/>
+          <a:ext cx="0" cy="0"/>
+          <a:chOff x="0" y="0"/>
+          <a:chExt cx="0" cy="0"/>
+        </a:xfrm>
+      </p:grpSpPr>
+      <p:sp>
+        <p:nvSpPr>
+          <p:cNvPr id="2" name="Header Placeholder 1"/>
+          <p:cNvSpPr>
+            <a:spLocks noGrp="1"/>
+          </p:cNvSpPr>
+          <p:nvPr>
+            <p:ph type="hdr" sz="quarter"/>
+          </p:nvPr>
+        </p:nvSpPr>
+        <p:spPr>
+          <a:xfrm>
+            <a:off x="0" y="0"/>
+            <a:ext cx="2971800" cy="457200"/>
+          </a:xfrm>
+          <a:prstGeom prst="rect">
+            <a:avLst/>
+          </a:prstGeom>
+        </p:spPr>
+        <p:txBody>
+          <a:bodyPr vert="horz" lIns="91440" tIns="45720" rIns="91440" bIns="45720" rtlCol="0"/>
+          <a:lstStyle>
+            <a:lvl1pPr algn="l">
+              <a:defRPr sz="1200"/>
+            </a:lvl1pPr>
+          </a:lstStyle>
+          <a:p>
+            <a:endParaRPr lang="en-US"/>
+          </a:p>
+        </p:txBody>
+      </p:sp>
+      <p:sp>
+        <p:nvSpPr>
+          <p:cNvPr id="3" name="Date Placeholder 2"/>
+          <p:cNvSpPr>
+            <a:spLocks noGrp="1"/>
+          </p:cNvSpPr>
+          <p:nvPr>
+            <p:ph type="dt" idx="1"/>
+          </p:nvPr>
+        </p:nvSpPr>
+        <p:spPr>
+          <a:xfrm>
+            <a:off x="3884613" y="0"/>
+            <a:ext cx="2971800" cy="457200"/>
+          </a:xfrm>
+          <a:prstGeom prst="rect">
+            <a:avLst/>
+          </a:prstGeom>
+        </p:spPr>
+        <p:txBody>
+          <a:bodyPr vert="horz" lIns="91440" tIns="45720" rIns="91440" bIns="45720" rtlCol="0"/>
+          <a:lstStyle>
+            <a:lvl1pPr algn="r">
+              <a:defRPr sz="1200"/>
+            </a:lvl1pPr>
+          </a:lstStyle>
+          <a:p>
+            <a:fld id="{0F89C1C7-3DCD-1040-A9CF-14679D8B5DDD}" type="datetimeFigureOut">
+              <a:rPr lang="en-US" smtClean="0"/>
+              <a:t>10/17/16</a:t>
+            </a:fld>
+            <a:endParaRPr lang="en-US"/>
+          </a:p>
+        </p:txBody>
+      </p:sp>
+      <p:sp>
+        <p:nvSpPr>
+          <p:cNvPr id="4" name="Slide Image Placeholder 3"/>
+          <p:cNvSpPr>
+            <a:spLocks noGrp="1" noRot="1" noChangeAspect="1"/>
+          </p:cNvSpPr>
+          <p:nvPr>
+            <p:ph type="sldImg" idx="2"/>
+          </p:nvPr>
+        </p:nvSpPr>
+        <p:spPr>
+          <a:xfrm>
+            <a:off x="1143000" y="685800"/>
+            <a:ext cx="4572000" cy="3429000"/>
+          </a:xfrm>
+          <a:prstGeom prst="rect">
+            <a:avLst/>
+          </a:prstGeom>
+          <a:noFill/>
+          <a:ln w="12700">
+            <a:solidFill>
+              <a:prstClr val="black"/>
+            </a:solidFill>
+          </a:ln>
+        </p:spPr>
+        <p:txBody>
+          <a:bodyPr vert="horz" lIns="91440" tIns="45720" rIns="91440" bIns="45720" rtlCol="0" anchor="ctr"/>
+          <a:lstStyle/>
+          <a:p>
+            <a:endParaRPr lang="en-US"/>
+          </a:p>
+        </p:txBody>
+      </p:sp>
+      <p:sp>
+        <p:nvSpPr>
+          <p:cNvPr id="5" name="Notes Placeholder 4"/>
+          <p:cNvSpPr>
+            <a:spLocks noGrp="1"/>
+          </p:cNvSpPr>
+          <p:nvPr>
+            <p:ph type="body" sz="quarter" idx="3"/>
+          </p:nvPr>
+        </p:nvSpPr>
+        <p:spPr>
+          <a:xfrm>
+            <a:off x="685800" y="4343400"/>
+            <a:ext cx="5486400" cy="4114800"/>
+          </a:xfrm>
+          <a:prstGeom prst="rect">
+            <a:avLst/>
+          </a:prstGeom>
+        </p:spPr>
+        <p:txBody>
+          <a:bodyPr vert="horz" lIns="91440" tIns="45720" rIns="91440" bIns="45720" rtlCol="0"/>
+          <a:lstStyle/>
+          <a:p>
+            <a:pPr lvl="0"/>
+            <a:r>
+              <a:rPr lang="en-US" smtClean="0"/>
+              <a:t>Click to edit Master text styles</a:t>
+            </a:r>
+          </a:p>
+          <a:p>
+            <a:pPr lvl="1"/>
+            <a:r>
+              <a:rPr lang="en-US" smtClean="0"/>
+              <a:t>Second level</a:t>
+            </a:r>
+          </a:p>
+          <a:p>
+            <a:pPr lvl="2"/>
+            <a:r>
+              <a:rPr lang="en-US" smtClean="0"/>
+              <a:t>Third level</a:t>
+            </a:r>
+          </a:p>
+          <a:p>
+            <a:pPr lvl="3"/>
+            <a:r>
+              <a:rPr lang="en-US" smtClean="0"/>
+              <a:t>Fourth level</a:t>
+            </a:r>
+          </a:p>
+          <a:p>
+            <a:pPr lvl="4"/>
+            <a:r>
+              <a:rPr lang="en-US" smtClean="0"/>
+              <a:t>Fifth level</a:t>
+            </a:r>
+            <a:endParaRPr lang="en-US"/>
+          </a:p>
+        </p:txBody>
+      </p:sp>
+      <p:sp>
+        <p:nvSpPr>
+          <p:cNvPr id="6" name="Footer Placeholder 5"/>
+          <p:cNvSpPr>
+            <a:spLocks noGrp="1"/>
+          </p:cNvSpPr>
+          <p:nvPr>
+            <p:ph type="ftr" sz="quarter" idx="4"/>
+          </p:nvPr>
+        </p:nvSpPr>
+        <p:spPr>
+          <a:xfrm>
+            <a:off x="0" y="8685213"/>
+            <a:ext cx="2971800" cy="457200"/>
+          </a:xfrm>
+          <a:prstGeom prst="rect">
+            <a:avLst/>
+          </a:prstGeom>
+        </p:spPr>
+        <p:txBody>
+          <a:bodyPr vert="horz" lIns="91440" tIns="45720" rIns="91440" bIns="45720" rtlCol="0" anchor="b"/>
+          <a:lstStyle>
+            <a:lvl1pPr algn="l">
+              <a:defRPr sz="1200"/>
+            </a:lvl1pPr>
+          </a:lstStyle>
+          <a:p>
+            <a:endParaRPr lang="en-US"/>
+          </a:p>
+        </p:txBody>
+      </p:sp>
+      <p:sp>
+        <p:nvSpPr>
+          <p:cNvPr id="7" name="Slide Number Placeholder 6"/>
+          <p:cNvSpPr>
+            <a:spLocks noGrp="1"/>
+          </p:cNvSpPr>
+          <p:nvPr>
+            <p:ph type="sldNum" sz="quarter" idx="5"/>
+          </p:nvPr>
+        </p:nvSpPr>
+        <p:spPr>
+          <a:xfrm>
+            <a:off x="3884613" y="8685213"/>
+            <a:ext cx="2971800" cy="457200"/>
+          </a:xfrm>
+          <a:prstGeom prst="rect">
+            <a:avLst/>
+          </a:prstGeom>
+        </p:spPr>
+        <p:txBody>
+          <a:bodyPr vert="horz" lIns="91440" tIns="45720" rIns="91440" bIns="45720" rtlCol="0" anchor="b"/>
+          <a:lstStyle>
+            <a:lvl1pPr algn="r">
+              <a:defRPr sz="1200"/>
+            </a:lvl1pPr>
+          </a:lstStyle>
+          <a:p>
+            <a:fld id="{BB5E49A5-4136-284D-997B-48E1D791AD67}" type="slidenum">
+              <a:rPr lang="en-US" smtClean="0"/>
+              <a:t>‹#›</a:t>
+            </a:fld>
+            <a:endParaRPr lang="en-US"/>
+          </a:p>
+        </p:txBody>
+      </p:sp>
+    </p:spTree>
+    <p:extLst>
+      <p:ext uri="{BB962C8B-B14F-4D97-AF65-F5344CB8AC3E}">
+        <p14:creationId xmlns:p14="http://schemas.microsoft.com/office/powerpoint/2010/main" val="2623252185"/>
+      </p:ext>
+    </p:extLst>
+  </p:cSld>
+  <p:clrMap bg1="lt1" tx1="dk1" bg2="lt2" tx2="dk2" accent1="accent1" accent2="accent2" accent3="accent3" accent4="accent4" accent5="accent5" accent6="accent6" hlink="hlink" folHlink="folHlink"/>
+  <p:notesStyle>
+    <a:lvl1pPr marL="0" algn="l" defTabSz="457200" rtl="0" eaLnBrk="1" latinLnBrk="0" hangingPunct="1">
+      <a:defRPr sz="1200" kern="1200">
+        <a:solidFill>
+          <a:schemeClr val="tx1"/>
+        </a:solidFill>
+        <a:latin typeface="+mn-lt"/>
+        <a:ea typeface="+mn-ea"/>
+        <a:cs typeface="+mn-cs"/>
+      </a:defRPr>
+    </a:lvl1pPr>
+    <a:lvl2pPr marL="457200" algn="l" defTabSz="457200" rtl="0" eaLnBrk="1" latinLnBrk="0" hangingPunct="1">
+      <a:defRPr sz="1200" kern="1200">
+        <a:solidFill>
+          <a:schemeClr val="tx1"/>
+        </a:solidFill>
+        <a:latin typeface="+mn-lt"/>
+        <a:ea typeface="+mn-ea"/>
+        <a:cs typeface="+mn-cs"/>
+      </a:defRPr>
+    </a:lvl2pPr>
+    <a:lvl3pPr marL="914400" algn="l" defTabSz="457200" rtl="0" eaLnBrk="1" latinLnBrk="0" hangingPunct="1">
+      <a:defRPr sz="1200" kern="1200">
+        <a:solidFill>
+          <a:schemeClr val="tx1"/>
+        </a:solidFill>
+        <a:latin typeface="+mn-lt"/>
+        <a:ea typeface="+mn-ea"/>
+        <a:cs typeface="+mn-cs"/>
+      </a:defRPr>
+    </a:lvl3pPr>
+    <a:lvl4pPr marL="1371600" algn="l" defTabSz="457200" rtl="0" eaLnBrk="1" latinLnBrk="0" hangingPunct="1">
+      <a:defRPr sz="1200" kern="1200">
+        <a:solidFill>
+          <a:schemeClr val="tx1"/>
+        </a:solidFill>
+        <a:latin typeface="+mn-lt"/>
+        <a:ea typeface="+mn-ea"/>
+        <a:cs typeface="+mn-cs"/>
+      </a:defRPr>
+    </a:lvl4pPr>
+    <a:lvl5pPr marL="1828800" algn="l" defTabSz="457200" rtl="0" eaLnBrk="1" latinLnBrk="0" hangingPunct="1">
+      <a:defRPr sz="1200" kern="1200">
+        <a:solidFill>
+          <a:schemeClr val="tx1"/>
+        </a:solidFill>
+        <a:latin typeface="+mn-lt"/>
+        <a:ea typeface="+mn-ea"/>
+        <a:cs typeface="+mn-cs"/>
+      </a:defRPr>
+    </a:lvl5pPr>
+    <a:lvl6pPr marL="2286000" algn="l" defTabSz="457200" rtl="0" eaLnBrk="1" latinLnBrk="0" hangingPunct="1">
+      <a:defRPr sz="1200" kern="1200">
+        <a:solidFill>
+          <a:schemeClr val="tx1"/>
+        </a:solidFill>
+        <a:latin typeface="+mn-lt"/>
+        <a:ea typeface="+mn-ea"/>
+        <a:cs typeface="+mn-cs"/>
+      </a:defRPr>
+    </a:lvl6pPr>
+    <a:lvl7pPr marL="2743200" algn="l" defTabSz="457200" rtl="0" eaLnBrk="1" latinLnBrk="0" hangingPunct="1">
+      <a:defRPr sz="1200" kern="1200">
+        <a:solidFill>
+          <a:schemeClr val="tx1"/>
+        </a:solidFill>
+        <a:latin typeface="+mn-lt"/>
+        <a:ea typeface="+mn-ea"/>
+        <a:cs typeface="+mn-cs"/>
+      </a:defRPr>
+    </a:lvl7pPr>
+    <a:lvl8pPr marL="3200400" algn="l" defTabSz="457200" rtl="0" eaLnBrk="1" latinLnBrk="0" hangingPunct="1">
+      <a:defRPr sz="1200" kern="1200">
+        <a:solidFill>
+          <a:schemeClr val="tx1"/>
+        </a:solidFill>
+        <a:latin typeface="+mn-lt"/>
+        <a:ea typeface="+mn-ea"/>
+        <a:cs typeface="+mn-cs"/>
+      </a:defRPr>
+    </a:lvl8pPr>
+    <a:lvl9pPr marL="3657600" algn="l" defTabSz="457200" rtl="0" eaLnBrk="1" latinLnBrk="0" hangingPunct="1">
+      <a:defRPr sz="1200" kern="1200">
+        <a:solidFill>
+          <a:schemeClr val="tx1"/>
+        </a:solidFill>
+        <a:latin typeface="+mn-lt"/>
+        <a:ea typeface="+mn-ea"/>
+        <a:cs typeface="+mn-cs"/>
+      </a:defRPr>
+    </a:lvl9pPr>
+  </p:notesStyle>
+</p:notesMaster>
+</file>
+
+<file path=ppt/notesSlides/notesSlide1.xml><?xml version="1.0" encoding="utf-8"?>
+<p:notes xmlns:a="http://schemas.openxmlformats.org/drawingml/2006/main" xmlns:p="http://schemas.openxmlformats.org/presentationml/2006/main" xmlns:r="http://schemas.openxmlformats.org/officeDocument/2006/relationships">
+  <p:cSld>
+    <p:spTree>
+      <p:nvGrpSpPr>
+        <p:cNvPr id="1" name=""/>
+        <p:cNvGrpSpPr/>
+        <p:nvPr/>
+      </p:nvGrpSpPr>
+      <p:grpSpPr>
+        <a:xfrm>
+          <a:off x="0" y="0"/>
+          <a:ext cx="0" cy="0"/>
+          <a:chOff x="0" y="0"/>
+          <a:chExt cx="0" cy="0"/>
+        </a:xfrm>
+      </p:grpSpPr>
+      <p:sp>
+        <p:nvSpPr>
+          <p:cNvPr id="2" name="Slide Image Placeholder 1"/>
+          <p:cNvSpPr>
+            <a:spLocks noGrp="1"/>
+          </p:cNvSpPr>
+          <p:nvPr>
+            <p:ph type="sldImg" idx="2"/>
+          </p:nvPr>
+        </p:nvSpPr>
+        <p:spPr/>
+      </p:sp>
+      <p:sp>
+        <p:nvSpPr>
+          <p:cNvPr id="3" name="Notes Placeholder 2"/>
+          <p:cNvSpPr>
+            <a:spLocks noGrp="1"/>
+          </p:cNvSpPr>
+          <p:nvPr>
+            <p:ph type="body" idx="3" sz="quarter"/>
+          </p:nvPr>
+        </p:nvSpPr>
+        <p:spPr/>
+        <p:txBody>
+          <a:bodyPr/>
+          <a:lstStyle/>
+          <a:p>
+            <a:r>
+              <a:t>Bienvenue dans ce module avancé. L'objectif n'est pas seulement d'écrire du SQL, mais de concevoir des architectures robustes et performantes. Nous allons explorer les fondamentaux théoriques, puis plonger dans la modélisation UML, l'optimisation des performances, et les requêtes analytiques avancées.</a:t>
+            </a:r>
+          </a:p>
+        </p:txBody>
+      </p:sp>
+      <p:sp>
+        <p:nvSpPr>
+          <p:cNvPr id="4" name="Slide Number Placeholder 3"/>
+          <p:cNvSpPr>
+            <a:spLocks noGrp="1"/>
+          </p:cNvSpPr>
+          <p:nvPr>
+            <p:ph type="sldNum" idx="5" sz="quarter"/>
+          </p:nvPr>
+        </p:nvSpPr>
+        <p:spPr/>
+      </p:sp>
+    </p:spTree>
+  </p:cSld>
+  <p:clrMapOvr>
+    <a:masterClrMapping/>
+  </p:clrMapOvr>
+</p:notes>
+</file>
+
+<file path=ppt/notesSlides/notesSlide2.xml><?xml version="1.0" encoding="utf-8"?>
+<p:notes xmlns:a="http://schemas.openxmlformats.org/drawingml/2006/main" xmlns:p="http://schemas.openxmlformats.org/presentationml/2006/main" xmlns:r="http://schemas.openxmlformats.org/officeDocument/2006/relationships">
+  <p:cSld>
+    <p:spTree>
+      <p:nvGrpSpPr>
+        <p:cNvPr id="1" name=""/>
+        <p:cNvGrpSpPr/>
+        <p:nvPr/>
+      </p:nvGrpSpPr>
+      <p:grpSpPr>
+        <a:xfrm>
+          <a:off x="0" y="0"/>
+          <a:ext cx="0" cy="0"/>
+          <a:chOff x="0" y="0"/>
+          <a:chExt cx="0" cy="0"/>
+        </a:xfrm>
+      </p:grpSpPr>
+      <p:sp>
+        <p:nvSpPr>
+          <p:cNvPr id="2" name="Slide Image Placeholder 1"/>
+          <p:cNvSpPr>
+            <a:spLocks noGrp="1"/>
+          </p:cNvSpPr>
+          <p:nvPr>
+            <p:ph type="sldImg" idx="2"/>
+          </p:nvPr>
+        </p:nvSpPr>
+        <p:spPr/>
+      </p:sp>
+      <p:sp>
+        <p:nvSpPr>
+          <p:cNvPr id="3" name="Notes Placeholder 2"/>
+          <p:cNvSpPr>
+            <a:spLocks noGrp="1"/>
+          </p:cNvSpPr>
+          <p:nvPr>
+            <p:ph type="body" idx="3" sz="quarter"/>
+          </p:nvPr>
+        </p:nvSpPr>
+        <p:spPr/>
+        <p:txBody>
+          <a:bodyPr/>
+          <a:lstStyle/>
+          <a:p>
+            <a:r>
+              <a:t>Le SGBD est souvent réduit à tort à un gros disque dur. Insistez sur le fait que le SGBD est le garant de l'intégrité métier. Sans lui, des transactions concurrentes corrompraient la base instantanément. Mentionnez le 'Write-Ahead Logging' (WAL) qui permet aux banques de ne jamais perdre une transaction même en cas de coupure de courant.</a:t>
+            </a:r>
+          </a:p>
+        </p:txBody>
+      </p:sp>
+      <p:sp>
+        <p:nvSpPr>
+          <p:cNvPr id="4" name="Slide Number Placeholder 3"/>
+          <p:cNvSpPr>
+            <a:spLocks noGrp="1"/>
+          </p:cNvSpPr>
+          <p:nvPr>
+            <p:ph type="sldNum" idx="5" sz="quarter"/>
+          </p:nvPr>
+        </p:nvSpPr>
+        <p:spPr/>
+      </p:sp>
+    </p:spTree>
+  </p:cSld>
+  <p:clrMapOvr>
+    <a:masterClrMapping/>
+  </p:clrMapOvr>
+</p:notes>
+</file>
+
+<file path=ppt/notesSlides/notesSlide3.xml><?xml version="1.0" encoding="utf-8"?>
+<p:notes xmlns:a="http://schemas.openxmlformats.org/drawingml/2006/main" xmlns:p="http://schemas.openxmlformats.org/presentationml/2006/main" xmlns:r="http://schemas.openxmlformats.org/officeDocument/2006/relationships">
+  <p:cSld>
+    <p:spTree>
+      <p:nvGrpSpPr>
+        <p:cNvPr id="1" name=""/>
+        <p:cNvGrpSpPr/>
+        <p:nvPr/>
+      </p:nvGrpSpPr>
+      <p:grpSpPr>
+        <a:xfrm>
+          <a:off x="0" y="0"/>
+          <a:ext cx="0" cy="0"/>
+          <a:chOff x="0" y="0"/>
+          <a:chExt cx="0" cy="0"/>
+        </a:xfrm>
+      </p:grpSpPr>
+      <p:sp>
+        <p:nvSpPr>
+          <p:cNvPr id="2" name="Slide Image Placeholder 1"/>
+          <p:cNvSpPr>
+            <a:spLocks noGrp="1"/>
+          </p:cNvSpPr>
+          <p:nvPr>
+            <p:ph type="sldImg" idx="2"/>
+          </p:nvPr>
+        </p:nvSpPr>
+        <p:spPr/>
+      </p:sp>
+      <p:sp>
+        <p:nvSpPr>
+          <p:cNvPr id="3" name="Notes Placeholder 2"/>
+          <p:cNvSpPr>
+            <a:spLocks noGrp="1"/>
+          </p:cNvSpPr>
+          <p:nvPr>
+            <p:ph type="body" idx="3" sz="quarter"/>
+          </p:nvPr>
+        </p:nvSpPr>
+        <p:spPr/>
+        <p:txBody>
+          <a:bodyPr/>
+          <a:lstStyle/>
+          <a:p>
+            <a:r>
+              <a:t>Le concept d'isolation est le plus subtil. Expliquez les 'Niveaux d'Isolation' (Read Uncommitted, Read Committed, Repeatable Read, Serializable). Un DBA doit souvent arbitrer entre le plus haut niveau d'isolation (sécurité maximale mais performances réduites à cause des verrous) et des niveaux inférieurs plus rapides.</a:t>
+            </a:r>
+          </a:p>
+        </p:txBody>
+      </p:sp>
+      <p:sp>
+        <p:nvSpPr>
+          <p:cNvPr id="4" name="Slide Number Placeholder 3"/>
+          <p:cNvSpPr>
+            <a:spLocks noGrp="1"/>
+          </p:cNvSpPr>
+          <p:nvPr>
+            <p:ph type="sldNum" idx="5" sz="quarter"/>
+          </p:nvPr>
+        </p:nvSpPr>
+        <p:spPr/>
+      </p:sp>
+    </p:spTree>
+  </p:cSld>
+  <p:clrMapOvr>
+    <a:masterClrMapping/>
+  </p:clrMapOvr>
+</p:notes>
+</file>
+
+<file path=ppt/notesSlides/notesSlide4.xml><?xml version="1.0" encoding="utf-8"?>
+<p:notes xmlns:a="http://schemas.openxmlformats.org/drawingml/2006/main" xmlns:p="http://schemas.openxmlformats.org/presentationml/2006/main" xmlns:r="http://schemas.openxmlformats.org/officeDocument/2006/relationships">
+  <p:cSld>
+    <p:spTree>
+      <p:nvGrpSpPr>
+        <p:cNvPr id="1" name=""/>
+        <p:cNvGrpSpPr/>
+        <p:nvPr/>
+      </p:nvGrpSpPr>
+      <p:grpSpPr>
+        <a:xfrm>
+          <a:off x="0" y="0"/>
+          <a:ext cx="0" cy="0"/>
+          <a:chOff x="0" y="0"/>
+          <a:chExt cx="0" cy="0"/>
+        </a:xfrm>
+      </p:grpSpPr>
+      <p:sp>
+        <p:nvSpPr>
+          <p:cNvPr id="2" name="Slide Image Placeholder 1"/>
+          <p:cNvSpPr>
+            <a:spLocks noGrp="1"/>
+          </p:cNvSpPr>
+          <p:nvPr>
+            <p:ph type="sldImg" idx="2"/>
+          </p:nvPr>
+        </p:nvSpPr>
+        <p:spPr/>
+      </p:sp>
+      <p:sp>
+        <p:nvSpPr>
+          <p:cNvPr id="3" name="Notes Placeholder 2"/>
+          <p:cNvSpPr>
+            <a:spLocks noGrp="1"/>
+          </p:cNvSpPr>
+          <p:nvPr>
+            <p:ph type="body" idx="3" sz="quarter"/>
+          </p:nvPr>
+        </p:nvSpPr>
+        <p:spPr/>
+        <p:txBody>
+          <a:bodyPr/>
+          <a:lstStyle/>
+          <a:p>
+            <a:r>
+              <a:t>Insistez sur la Table de Jonction (Junction Table). Une erreur classique de débutant est d'essayer de stocker des valeurs multiples séparées par des virgules dans une seule colonne. Cela casse complètement le modèle relationnel et les performances de requêtage.</a:t>
+            </a:r>
+          </a:p>
+        </p:txBody>
+      </p:sp>
+      <p:sp>
+        <p:nvSpPr>
+          <p:cNvPr id="4" name="Slide Number Placeholder 3"/>
+          <p:cNvSpPr>
+            <a:spLocks noGrp="1"/>
+          </p:cNvSpPr>
+          <p:nvPr>
+            <p:ph type="sldNum" idx="5" sz="quarter"/>
+          </p:nvPr>
+        </p:nvSpPr>
+        <p:spPr/>
+      </p:sp>
+    </p:spTree>
+  </p:cSld>
+  <p:clrMapOvr>
+    <a:masterClrMapping/>
+  </p:clrMapOvr>
+</p:notes>
+</file>
+
+<file path=ppt/notesSlides/notesSlide5.xml><?xml version="1.0" encoding="utf-8"?>
+<p:notes xmlns:a="http://schemas.openxmlformats.org/drawingml/2006/main" xmlns:p="http://schemas.openxmlformats.org/presentationml/2006/main" xmlns:r="http://schemas.openxmlformats.org/officeDocument/2006/relationships">
+  <p:cSld>
+    <p:spTree>
+      <p:nvGrpSpPr>
+        <p:cNvPr id="1" name=""/>
+        <p:cNvGrpSpPr/>
+        <p:nvPr/>
+      </p:nvGrpSpPr>
+      <p:grpSpPr>
+        <a:xfrm>
+          <a:off x="0" y="0"/>
+          <a:ext cx="0" cy="0"/>
+          <a:chOff x="0" y="0"/>
+          <a:chExt cx="0" cy="0"/>
+        </a:xfrm>
+      </p:grpSpPr>
+      <p:sp>
+        <p:nvSpPr>
+          <p:cNvPr id="2" name="Slide Image Placeholder 1"/>
+          <p:cNvSpPr>
+            <a:spLocks noGrp="1"/>
+          </p:cNvSpPr>
+          <p:nvPr>
+            <p:ph type="sldImg" idx="2"/>
+          </p:nvPr>
+        </p:nvSpPr>
+        <p:spPr/>
+      </p:sp>
+      <p:sp>
+        <p:nvSpPr>
+          <p:cNvPr id="3" name="Notes Placeholder 2"/>
+          <p:cNvSpPr>
+            <a:spLocks noGrp="1"/>
+          </p:cNvSpPr>
+          <p:nvPr>
+            <p:ph type="body" idx="3" sz="quarter"/>
+          </p:nvPr>
+        </p:nvSpPr>
+        <p:spPr/>
+        <p:txBody>
+          <a:bodyPr/>
+          <a:lstStyle/>
+          <a:p>
+            <a:r>
+              <a:t>La 3ème Forme Normale (3NF) est le standard d'or de l'industrie. La phrase mnémotechnique de Bill Kent : 'Every non-key attribute must provide a fact about the key, the whole key, and nothing but the key, so help me Codd.' Mentionnez que dans les entrepôts de données (Data Warehouses) pour la BI, on effectue souvent le processus inverse : la 'Dénormalisation', pour accélérer la lecture.</a:t>
+            </a:r>
+          </a:p>
+        </p:txBody>
+      </p:sp>
+      <p:sp>
+        <p:nvSpPr>
+          <p:cNvPr id="4" name="Slide Number Placeholder 3"/>
+          <p:cNvSpPr>
+            <a:spLocks noGrp="1"/>
+          </p:cNvSpPr>
+          <p:nvPr>
+            <p:ph type="sldNum" idx="5" sz="quarter"/>
+          </p:nvPr>
+        </p:nvSpPr>
+        <p:spPr/>
+      </p:sp>
+    </p:spTree>
+  </p:cSld>
+  <p:clrMapOvr>
+    <a:masterClrMapping/>
+  </p:clrMapOvr>
+</p:notes>
+</file>
+
+<file path=ppt/notesSlides/notesSlide6.xml><?xml version="1.0" encoding="utf-8"?>
+<p:notes xmlns:a="http://schemas.openxmlformats.org/drawingml/2006/main" xmlns:p="http://schemas.openxmlformats.org/presentationml/2006/main" xmlns:r="http://schemas.openxmlformats.org/officeDocument/2006/relationships">
+  <p:cSld>
+    <p:spTree>
+      <p:nvGrpSpPr>
+        <p:cNvPr id="1" name=""/>
+        <p:cNvGrpSpPr/>
+        <p:nvPr/>
+      </p:nvGrpSpPr>
+      <p:grpSpPr>
+        <a:xfrm>
+          <a:off x="0" y="0"/>
+          <a:ext cx="0" cy="0"/>
+          <a:chOff x="0" y="0"/>
+          <a:chExt cx="0" cy="0"/>
+        </a:xfrm>
+      </p:grpSpPr>
+      <p:sp>
+        <p:nvSpPr>
+          <p:cNvPr id="2" name="Slide Image Placeholder 1"/>
+          <p:cNvSpPr>
+            <a:spLocks noGrp="1"/>
+          </p:cNvSpPr>
+          <p:nvPr>
+            <p:ph type="sldImg" idx="2"/>
+          </p:nvPr>
+        </p:nvSpPr>
+        <p:spPr/>
+      </p:sp>
+      <p:sp>
+        <p:nvSpPr>
+          <p:cNvPr id="3" name="Notes Placeholder 2"/>
+          <p:cNvSpPr>
+            <a:spLocks noGrp="1"/>
+          </p:cNvSpPr>
+          <p:nvPr>
+            <p:ph type="body" idx="3" sz="quarter"/>
+          </p:nvPr>
+        </p:nvSpPr>
+        <p:spPr/>
+        <p:txBody>
+          <a:bodyPr/>
+          <a:lstStyle/>
+          <a:p>
+            <a:r>
+              <a:t>Si une requête SQL est lente, la solution n'est presque jamais 'le SGBD est mauvais'. C'est généralement un manque d'index ou une requête mal formulée qui force le SGBD à faire un 'Full Table Scan' (lecture complète de la table). L'instruction EXPLAIN permet de lire dans les pensées de l'optimiseur de requêtes.</a:t>
+            </a:r>
+          </a:p>
+        </p:txBody>
+      </p:sp>
+      <p:sp>
+        <p:nvSpPr>
+          <p:cNvPr id="4" name="Slide Number Placeholder 3"/>
+          <p:cNvSpPr>
+            <a:spLocks noGrp="1"/>
+          </p:cNvSpPr>
+          <p:nvPr>
+            <p:ph type="sldNum" idx="5" sz="quarter"/>
+          </p:nvPr>
+        </p:nvSpPr>
+        <p:spPr/>
+      </p:sp>
+    </p:spTree>
+  </p:cSld>
+  <p:clrMapOvr>
+    <a:masterClrMapping/>
+  </p:clrMapOvr>
+</p:notes>
+</file>
+
+<file path=ppt/notesSlides/notesSlide7.xml><?xml version="1.0" encoding="utf-8"?>
+<p:notes xmlns:a="http://schemas.openxmlformats.org/drawingml/2006/main" xmlns:p="http://schemas.openxmlformats.org/presentationml/2006/main" xmlns:r="http://schemas.openxmlformats.org/officeDocument/2006/relationships">
+  <p:cSld>
+    <p:spTree>
+      <p:nvGrpSpPr>
+        <p:cNvPr id="1" name=""/>
+        <p:cNvGrpSpPr/>
+        <p:nvPr/>
+      </p:nvGrpSpPr>
+      <p:grpSpPr>
+        <a:xfrm>
+          <a:off x="0" y="0"/>
+          <a:ext cx="0" cy="0"/>
+          <a:chOff x="0" y="0"/>
+          <a:chExt cx="0" cy="0"/>
+        </a:xfrm>
+      </p:grpSpPr>
+      <p:sp>
+        <p:nvSpPr>
+          <p:cNvPr id="2" name="Slide Image Placeholder 1"/>
+          <p:cNvSpPr>
+            <a:spLocks noGrp="1"/>
+          </p:cNvSpPr>
+          <p:nvPr>
+            <p:ph type="sldImg" idx="2"/>
+          </p:nvPr>
+        </p:nvSpPr>
+        <p:spPr/>
+      </p:sp>
+      <p:sp>
+        <p:nvSpPr>
+          <p:cNvPr id="3" name="Notes Placeholder 2"/>
+          <p:cNvSpPr>
+            <a:spLocks noGrp="1"/>
+          </p:cNvSpPr>
+          <p:nvPr>
+            <p:ph type="body" idx="3" sz="quarter"/>
+          </p:nvPr>
+        </p:nvSpPr>
+        <p:spPr/>
+        <p:txBody>
+          <a:bodyPr/>
+          <a:lstStyle/>
+          <a:p>
+            <a:r>
+              <a:t>Rappelez que l'UML est universel. Si un architecte produit un bon diagramme de classes UML, n'importe quel développeur ou outil de génération de code peut le traduire automatiquement en script SQL DDL. La composition (losange plein) implique une dépendance existentielle forte : si je supprime une Commande, ses Lignes_de_Commande doivent être détruites en cascade (ON DELETE CASCADE).</a:t>
+            </a:r>
+          </a:p>
+        </p:txBody>
+      </p:sp>
+      <p:sp>
+        <p:nvSpPr>
+          <p:cNvPr id="4" name="Slide Number Placeholder 3"/>
+          <p:cNvSpPr>
+            <a:spLocks noGrp="1"/>
+          </p:cNvSpPr>
+          <p:nvPr>
+            <p:ph type="sldNum" idx="5" sz="quarter"/>
+          </p:nvPr>
+        </p:nvSpPr>
+        <p:spPr/>
+      </p:sp>
+    </p:spTree>
+  </p:cSld>
+  <p:clrMapOvr>
+    <a:masterClrMapping/>
+  </p:clrMapOvr>
+</p:notes>
+</file>
+
+<file path=ppt/notesSlides/notesSlide8.xml><?xml version="1.0" encoding="utf-8"?>
+<p:notes xmlns:a="http://schemas.openxmlformats.org/drawingml/2006/main" xmlns:p="http://schemas.openxmlformats.org/presentationml/2006/main" xmlns:r="http://schemas.openxmlformats.org/officeDocument/2006/relationships">
+  <p:cSld>
+    <p:spTree>
+      <p:nvGrpSpPr>
+        <p:cNvPr id="1" name=""/>
+        <p:cNvGrpSpPr/>
+        <p:nvPr/>
+      </p:nvGrpSpPr>
+      <p:grpSpPr>
+        <a:xfrm>
+          <a:off x="0" y="0"/>
+          <a:ext cx="0" cy="0"/>
+          <a:chOff x="0" y="0"/>
+          <a:chExt cx="0" cy="0"/>
+        </a:xfrm>
+      </p:grpSpPr>
+      <p:sp>
+        <p:nvSpPr>
+          <p:cNvPr id="2" name="Slide Image Placeholder 1"/>
+          <p:cNvSpPr>
+            <a:spLocks noGrp="1"/>
+          </p:cNvSpPr>
+          <p:nvPr>
+            <p:ph type="sldImg" idx="2"/>
+          </p:nvPr>
+        </p:nvSpPr>
+        <p:spPr/>
+      </p:sp>
+      <p:sp>
+        <p:nvSpPr>
+          <p:cNvPr id="3" name="Notes Placeholder 2"/>
+          <p:cNvSpPr>
+            <a:spLocks noGrp="1"/>
+          </p:cNvSpPr>
+          <p:nvPr>
+            <p:ph type="body" idx="3" sz="quarter"/>
+          </p:nvPr>
+        </p:nvSpPr>
+        <p:spPr/>
+        <p:txBody>
+          <a:bodyPr/>
+          <a:lstStyle/>
+          <a:p>
+            <a:r>
+              <a:t>Ne confondez jamais WHERE et HAVING. Le WHERE filtre les lignes avant le calcul. Le HAVING filtre le résultat du calcul (ex: afficher les catégories dont la moyenne est &gt; 100).</a:t>
+            </a:r>
+          </a:p>
+        </p:txBody>
+      </p:sp>
+      <p:sp>
+        <p:nvSpPr>
+          <p:cNvPr id="4" name="Slide Number Placeholder 3"/>
+          <p:cNvSpPr>
+            <a:spLocks noGrp="1"/>
+          </p:cNvSpPr>
+          <p:nvPr>
+            <p:ph type="sldNum" idx="5" sz="quarter"/>
+          </p:nvPr>
+        </p:nvSpPr>
+        <p:spPr/>
+      </p:sp>
+    </p:spTree>
+  </p:cSld>
+  <p:clrMapOvr>
+    <a:masterClrMapping/>
+  </p:clrMapOvr>
+</p:notes>
+</file>
+
+<file path=ppt/notesSlides/notesSlide9.xml><?xml version="1.0" encoding="utf-8"?>
+<p:notes xmlns:a="http://schemas.openxmlformats.org/drawingml/2006/main" xmlns:p="http://schemas.openxmlformats.org/presentationml/2006/main" xmlns:r="http://schemas.openxmlformats.org/officeDocument/2006/relationships">
+  <p:cSld>
+    <p:spTree>
+      <p:nvGrpSpPr>
+        <p:cNvPr id="1" name=""/>
+        <p:cNvGrpSpPr/>
+        <p:nvPr/>
+      </p:nvGrpSpPr>
+      <p:grpSpPr>
+        <a:xfrm>
+          <a:off x="0" y="0"/>
+          <a:ext cx="0" cy="0"/>
+          <a:chOff x="0" y="0"/>
+          <a:chExt cx="0" cy="0"/>
+        </a:xfrm>
+      </p:grpSpPr>
+      <p:sp>
+        <p:nvSpPr>
+          <p:cNvPr id="2" name="Slide Image Placeholder 1"/>
+          <p:cNvSpPr>
+            <a:spLocks noGrp="1"/>
+          </p:cNvSpPr>
+          <p:nvPr>
+            <p:ph type="sldImg" idx="2"/>
+          </p:nvPr>
+        </p:nvSpPr>
+        <p:spPr/>
+      </p:sp>
+      <p:sp>
+        <p:nvSpPr>
+          <p:cNvPr id="3" name="Notes Placeholder 2"/>
+          <p:cNvSpPr>
+            <a:spLocks noGrp="1"/>
+          </p:cNvSpPr>
+          <p:nvPr>
+            <p:ph type="body" idx="3" sz="quarter"/>
+          </p:nvPr>
+        </p:nvSpPr>
+        <p:spPr/>
+        <p:txBody>
+          <a:bodyPr/>
+          <a:lstStyle/>
+          <a:p>
+            <a:r>
+              <a:t>C'est ici que l'on sépare les juniors des seniors en SQL. Les CTEs (clause WITH) permettent d'écrire des scripts d'analyse clairs comme du code impératif. Les Window Functions sont essentielles en Data Science et BI pour faire du tracking temporel (LAG/LEAD) sans faire de jointures croisées complexes.</a:t>
+            </a:r>
+          </a:p>
+        </p:txBody>
+      </p:sp>
+      <p:sp>
+        <p:nvSpPr>
+          <p:cNvPr id="4" name="Slide Number Placeholder 3"/>
+          <p:cNvSpPr>
+            <a:spLocks noGrp="1"/>
+          </p:cNvSpPr>
+          <p:nvPr>
+            <p:ph type="sldNum" idx="5" sz="quarter"/>
+          </p:nvPr>
+        </p:nvSpPr>
+        <p:spPr/>
+      </p:sp>
+    </p:spTree>
+  </p:cSld>
+  <p:clrMapOvr>
+    <a:masterClrMapping/>
+  </p:clrMapOvr>
+</p:notes>
 </file>
 
 <file path=ppt/slideLayouts/slideLayout1.xml><?xml version="1.0" encoding="utf-8"?>
@@ -3123,7 +4106,7 @@
               </a:defRPr>
             </a:pPr>
             <a:r>
-              <a:t>Bases de données : Modélisation et SQL</a:t>
+              <a:t>Ingénierie de la Donnée : Modélisation Avancée et SQL</a:t>
             </a:r>
           </a:p>
         </p:txBody>
@@ -3152,7 +4135,7 @@
               </a:defRPr>
             </a:pPr>
             <a:r>
-              <a:t>Cours Complet, de la Conception à l'Analyse</a:t>
+              <a:t>Architecture Relationnelle, Optimisation et Analyse de Données</a:t>
             </a:r>
           </a:p>
         </p:txBody>
@@ -3223,7 +4206,7 @@
               </a:defRPr>
             </a:pPr>
             <a:r>
-              <a:t>9. Le Langage SQL : Manipulation des Données</a:t>
+              <a:t>7. Modélisation Conceptuelle avec UML</a:t>
             </a:r>
           </a:p>
         </p:txBody>
@@ -3259,7 +4242,7 @@
               </a:defRPr>
             </a:pPr>
             <a:r>
-              <a:t>Insertion</a:t>
+              <a:t>Diagramme de Classes UML</a:t>
             </a:r>
           </a:p>
           <a:p>
@@ -3267,19 +4250,35 @@
               <a:defRPr sz="1400"/>
             </a:pPr>
             <a:r>
-              <a:t>INSERT INTO table (col1, col2) VALUES (val1, val2);</a:t>
+              <a:t>Le nom de la relation en haut.</a:t>
+            </a:r>
+          </a:p>
+          <a:p>
+            <a:pPr lvl="1">
+              <a:defRPr sz="1400"/>
+            </a:pPr>
+            <a:r>
+              <a:t>La liste des colonnes en bas : nom_colonne: type(longueur).</a:t>
+            </a:r>
+          </a:p>
+          <a:p>
+            <a:pPr lvl="1">
+              <a:defRPr sz="1400"/>
+            </a:pPr>
+            <a:r>
+              <a:t>Les Clés Primaires sont soulignées, les Clés Étrangères précédées d'un #.</a:t>
             </a:r>
           </a:p>
           <a:p>
             <a:pPr>
               <a:defRPr b="1" sz="1800">
                 <a:solidFill>
-                  <a:srgbClr val="282828"/>
-                </a:solidFill>
-              </a:defRPr>
-            </a:pPr>
-            <a:r>
-              <a:t>Modification</a:t>
+                  <a:srgbClr val="ED1C24"/>
+                </a:solidFill>
+              </a:defRPr>
+            </a:pPr>
+            <a:r>
+              <a:t>Agrégation et Composition</a:t>
             </a:r>
           </a:p>
           <a:p>
@@ -3287,19 +4286,7 @@
               <a:defRPr sz="1400"/>
             </a:pPr>
             <a:r>
-              <a:t>UPDATE table SET col1 = val1 WHERE condition;</a:t>
-            </a:r>
-          </a:p>
-          <a:p>
-            <a:pPr>
-              <a:defRPr b="1" sz="1800">
-                <a:solidFill>
-                  <a:srgbClr val="282828"/>
-                </a:solidFill>
-              </a:defRPr>
-            </a:pPr>
-            <a:r>
-              <a:t>Suppression</a:t>
+              <a:t>Agrégation : Lien simple (ex: une maison est une agrégation de murs).</a:t>
             </a:r>
           </a:p>
           <a:p>
@@ -3307,35 +4294,7 @@
               <a:defRPr sz="1400"/>
             </a:pPr>
             <a:r>
-              <a:t>DELETE FROM table WHERE condition;</a:t>
-            </a:r>
-          </a:p>
-          <a:p>
-            <a:pPr>
-              <a:defRPr b="1" sz="1800">
-                <a:solidFill>
-                  <a:srgbClr val="ED1C24"/>
-                </a:solidFill>
-              </a:defRPr>
-            </a:pPr>
-            <a:r>
-              <a:t>Qualité de Données (LinkedIn Learning)</a:t>
-            </a:r>
-          </a:p>
-          <a:p>
-            <a:pPr lvl="1">
-              <a:defRPr sz="1400"/>
-            </a:pPr>
-            <a:r>
-              <a:t>Le SQL est indispensable pour le nettoyage (Data Wrangling).</a:t>
-            </a:r>
-          </a:p>
-          <a:p>
-            <a:pPr lvl="1">
-              <a:defRPr sz="1400"/>
-            </a:pPr>
-            <a:r>
-              <a:t>Permet de gérer massivement les formats mixtes ou les données manquantes (NULL).</a:t>
+              <a:t>Composition : Agrégation forte, la destruction du tout détruit la partie (ex: école et cycles scolaires).</a:t>
             </a:r>
           </a:p>
         </p:txBody>
@@ -3394,7 +4353,7 @@
             </a:r>
             <a:br/>
             <a:r>
-              <a:t>Code snippet : Une requête UPDATE corrigeant une faute de frappe dans un dataset sale.</a:t>
+              <a:t>Exemple de formalisme UML strict avec une table d'association.</a:t>
             </a:r>
           </a:p>
         </p:txBody>
@@ -3465,7 +4424,7 @@
               </a:defRPr>
             </a:pPr>
             <a:r>
-              <a:t>10. Le Langage SQL : Requêtes d'Analyse (1/2)</a:t>
+              <a:t>8. Le Langage SQL : Définition des Données</a:t>
             </a:r>
           </a:p>
         </p:txBody>
@@ -3501,7 +4460,7 @@
               </a:defRPr>
             </a:pPr>
             <a:r>
-              <a:t>Projection et Sélection</a:t>
+              <a:t>Architecture Client-Serveur</a:t>
             </a:r>
           </a:p>
           <a:p>
@@ -3509,7 +4468,19 @@
               <a:defRPr sz="1400"/>
             </a:pPr>
             <a:r>
-              <a:t>SELECT col1, col2 FROM table WHERE condition;</a:t>
+              <a:t>Le client (ex: DBeaver) envoie des requêtes SQL au serveur (ex: PostgreSQL).</a:t>
+            </a:r>
+          </a:p>
+          <a:p>
+            <a:pPr>
+              <a:defRPr b="1" sz="1800">
+                <a:solidFill>
+                  <a:srgbClr val="ED1C24"/>
+                </a:solidFill>
+              </a:defRPr>
+            </a:pPr>
+            <a:r>
+              <a:t>Création de Tables (DDL)</a:t>
             </a:r>
           </a:p>
           <a:p>
@@ -3517,19 +4488,27 @@
               <a:defRPr sz="1400"/>
             </a:pPr>
             <a:r>
-              <a:t>Utilisation de l'opérateur LIKE avec '%' pour les recherches textuelles.</a:t>
+              <a:t>Syntaxe : CREATE TABLE nom (colonne1 type, colonne2 type);</a:t>
+            </a:r>
+          </a:p>
+          <a:p>
+            <a:pPr lvl="1">
+              <a:defRPr sz="1400"/>
+            </a:pPr>
+            <a:r>
+              <a:t>Contraintes : NOT NULL, PRIMARY KEY, UNIQUE, CHECK(condition).</a:t>
             </a:r>
           </a:p>
           <a:p>
             <a:pPr>
               <a:defRPr b="1" sz="1800">
                 <a:solidFill>
-                  <a:srgbClr val="ED1C24"/>
-                </a:solidFill>
-              </a:defRPr>
-            </a:pPr>
-            <a:r>
-              <a:t>La Jointure (JOIN)</a:t>
+                  <a:srgbClr val="282828"/>
+                </a:solidFill>
+              </a:defRPr>
+            </a:pPr>
+            <a:r>
+              <a:t>Modification</a:t>
             </a:r>
           </a:p>
           <a:p>
@@ -3537,7 +4516,7 @@
               <a:defRPr sz="1400"/>
             </a:pPr>
             <a:r>
-              <a:t>Pour relier les données de plusieurs tables.</a:t>
+              <a:t>ALTER TABLE : Ajouter, supprimer des colonnes ou des contraintes.</a:t>
             </a:r>
           </a:p>
           <a:p>
@@ -3545,7 +4524,7 @@
               <a:defRPr sz="1400"/>
             </a:pPr>
             <a:r>
-              <a:t>SELECT * FROM tableA JOIN tableB ON tableA.id = tableB.fk_id;</a:t>
+              <a:t>DROP TABLE : Supprimer une table.</a:t>
             </a:r>
           </a:p>
         </p:txBody>
@@ -3604,7 +4583,7 @@
             </a:r>
             <a:br/>
             <a:r>
-              <a:t>Un schéma d'ensembles de Venn montrant le fonctionnement d'une Jointure (l'intersection).</a:t>
+              <a:t>Capture d'écran de l'interface DBeaver connectée à une base PostgreSQL.</a:t>
             </a:r>
           </a:p>
         </p:txBody>
@@ -3675,7 +4654,7 @@
               </a:defRPr>
             </a:pPr>
             <a:r>
-              <a:t>11. Le Langage SQL : Requêtes d'Analyse (2/2)</a:t>
+              <a:t>9. Le Langage SQL : Manipulation des Données</a:t>
             </a:r>
           </a:p>
         </p:txBody>
@@ -3711,7 +4690,7 @@
               </a:defRPr>
             </a:pPr>
             <a:r>
-              <a:t>Fonctions d'Agrégation</a:t>
+              <a:t>Insertion</a:t>
             </a:r>
           </a:p>
           <a:p>
@@ -3719,7 +4698,19 @@
               <a:defRPr sz="1400"/>
             </a:pPr>
             <a:r>
-              <a:t>COUNT(), AVG(), SUM(), MIN(), MAX().</a:t>
+              <a:t>INSERT INTO table (col1, col2) VALUES (val1, val2);</a:t>
+            </a:r>
+          </a:p>
+          <a:p>
+            <a:pPr>
+              <a:defRPr b="1" sz="1800">
+                <a:solidFill>
+                  <a:srgbClr val="282828"/>
+                </a:solidFill>
+              </a:defRPr>
+            </a:pPr>
+            <a:r>
+              <a:t>Modification</a:t>
             </a:r>
           </a:p>
           <a:p>
@@ -3727,19 +4718,19 @@
               <a:defRPr sz="1400"/>
             </a:pPr>
             <a:r>
-              <a:t>Le regroupement via GROUP BY pour analyser par catégorie.</a:t>
+              <a:t>UPDATE table SET col1 = val1 WHERE condition;</a:t>
             </a:r>
           </a:p>
           <a:p>
             <a:pPr>
               <a:defRPr b="1" sz="1800">
                 <a:solidFill>
-                  <a:srgbClr val="ED1C24"/>
-                </a:solidFill>
-              </a:defRPr>
-            </a:pPr>
-            <a:r>
-              <a:t>Fonctions de Fenêtrage (LinkedIn Learning)</a:t>
+                  <a:srgbClr val="282828"/>
+                </a:solidFill>
+              </a:defRPr>
+            </a:pPr>
+            <a:r>
+              <a:t>Suppression</a:t>
             </a:r>
           </a:p>
           <a:p>
@@ -3747,7 +4738,19 @@
               <a:defRPr sz="1400"/>
             </a:pPr>
             <a:r>
-              <a:t>Pour l'analyse statistique avancée sur PostgreSQL.</a:t>
+              <a:t>DELETE FROM table WHERE condition;</a:t>
+            </a:r>
+          </a:p>
+          <a:p>
+            <a:pPr>
+              <a:defRPr b="1" sz="1800">
+                <a:solidFill>
+                  <a:srgbClr val="ED1C24"/>
+                </a:solidFill>
+              </a:defRPr>
+            </a:pPr>
+            <a:r>
+              <a:t>Qualité de Données (LinkedIn Learning)</a:t>
             </a:r>
           </a:p>
           <a:p>
@@ -3755,7 +4758,7 @@
               <a:defRPr sz="1400"/>
             </a:pPr>
             <a:r>
-              <a:t>Syntaxe : OVER(), PARTITION BY().</a:t>
+              <a:t>Le SQL est indispensable pour le nettoyage (Data Wrangling).</a:t>
             </a:r>
           </a:p>
           <a:p>
@@ -3763,7 +4766,7 @@
               <a:defRPr sz="1400"/>
             </a:pPr>
             <a:r>
-              <a:t>Permet de calculer des totaux cumulés ou des rangs sans réduire le nombre de lignes (contrairement à GROUP BY).</a:t>
+              <a:t>Permet de gérer massivement les formats mixtes ou les données manquantes (NULL).</a:t>
             </a:r>
           </a:p>
         </p:txBody>
@@ -3822,7 +4825,7 @@
             </a:r>
             <a:br/>
             <a:r>
-              <a:t>Tableau de bord minimaliste montrant des résultats agrégés par région.</a:t>
+              <a:t>Code snippet : Une requête UPDATE corrigeant une faute de frappe dans un dataset sale.</a:t>
             </a:r>
           </a:p>
         </p:txBody>
@@ -3835,7 +4838,7 @@
 </p:sld>
 </file>
 
-<file path=ppt/slides/slide2.xml><?xml version="1.0" encoding="utf-8"?>
+<file path=ppt/slides/slide13.xml><?xml version="1.0" encoding="utf-8"?>
 <p:sld xmlns:a="http://schemas.openxmlformats.org/drawingml/2006/main" xmlns:p="http://schemas.openxmlformats.org/presentationml/2006/main" xmlns:r="http://schemas.openxmlformats.org/officeDocument/2006/relationships">
   <p:cSld>
     <p:spTree>
@@ -3893,7 +4896,7 @@
               </a:defRPr>
             </a:pPr>
             <a:r>
-              <a:t>1. Généralités sur les Bases de Données</a:t>
+              <a:t>10. Le Langage SQL : Requêtes d'Analyse (1/2)</a:t>
             </a:r>
           </a:p>
         </p:txBody>
@@ -3929,7 +4932,7 @@
               </a:defRPr>
             </a:pPr>
             <a:r>
-              <a:t>Définition</a:t>
+              <a:t>Projection et Sélection</a:t>
             </a:r>
           </a:p>
           <a:p>
@@ -3937,19 +4940,27 @@
               <a:defRPr sz="1400"/>
             </a:pPr>
             <a:r>
-              <a:t>Un ensemble de données stockées et structurées informatiquement pour faciliter la consultation et la modification.</a:t>
+              <a:t>SELECT col1, col2 FROM table WHERE condition;</a:t>
+            </a:r>
+          </a:p>
+          <a:p>
+            <a:pPr lvl="1">
+              <a:defRPr sz="1400"/>
+            </a:pPr>
+            <a:r>
+              <a:t>Utilisation de l'opérateur LIKE avec '%' pour les recherches textuelles.</a:t>
             </a:r>
           </a:p>
           <a:p>
             <a:pPr>
               <a:defRPr b="1" sz="1800">
                 <a:solidFill>
-                  <a:srgbClr val="282828"/>
-                </a:solidFill>
-              </a:defRPr>
-            </a:pPr>
-            <a:r>
-              <a:t>Le Rôle du SGBD</a:t>
+                  <a:srgbClr val="ED1C24"/>
+                </a:solidFill>
+              </a:defRPr>
+            </a:pPr>
+            <a:r>
+              <a:t>La Jointure (JOIN)</a:t>
             </a:r>
           </a:p>
           <a:p>
@@ -3957,7 +4968,7 @@
               <a:defRPr sz="1400"/>
             </a:pPr>
             <a:r>
-              <a:t>Le Système de Gestion de Bases de Données est le logiciel intermédiaire.</a:t>
+              <a:t>Pour relier les données de plusieurs tables.</a:t>
             </a:r>
           </a:p>
           <a:p>
@@ -3965,15 +4976,7 @@
               <a:defRPr sz="1400"/>
             </a:pPr>
             <a:r>
-              <a:t>Il gère la cohérence des données, les accès multiples (concurrents) et la sécurité.</a:t>
-            </a:r>
-          </a:p>
-          <a:p>
-            <a:pPr lvl="1">
-              <a:defRPr sz="1400"/>
-            </a:pPr>
-            <a:r>
-              <a:t>Il assure la reprise sur incident (ex: annulation après une coupure de courant).</a:t>
+              <a:t>SELECT * FROM tableA JOIN tableB ON tableA.id = tableB.fk_id;</a:t>
             </a:r>
           </a:p>
         </p:txBody>
@@ -4032,7 +5035,7 @@
             </a:r>
             <a:br/>
             <a:r>
-              <a:t>Schéma: Utilisateur -&gt; SGBD -&gt; Fichiers de la base de données sur disque dur.</a:t>
+              <a:t>Un schéma d'ensembles de Venn montrant le fonctionnement d'une Jointure (l'intersection).</a:t>
             </a:r>
           </a:p>
         </p:txBody>
@@ -4045,7 +5048,7 @@
 </p:sld>
 </file>
 
-<file path=ppt/slides/slide3.xml><?xml version="1.0" encoding="utf-8"?>
+<file path=ppt/slides/slide14.xml><?xml version="1.0" encoding="utf-8"?>
 <p:sld xmlns:a="http://schemas.openxmlformats.org/drawingml/2006/main" xmlns:p="http://schemas.openxmlformats.org/presentationml/2006/main" xmlns:r="http://schemas.openxmlformats.org/officeDocument/2006/relationships">
   <p:cSld>
     <p:spTree>
@@ -4103,7 +5106,7 @@
               </a:defRPr>
             </a:pPr>
             <a:r>
-              <a:t>2. Les Différents Types de SGBD (Historique)</a:t>
+              <a:t>12. L'Analyse Data avec SQL : Agrégations</a:t>
             </a:r>
           </a:p>
         </p:txBody>
@@ -4139,7 +5142,7 @@
               </a:defRPr>
             </a:pPr>
             <a:r>
-              <a:t>Années 1960</a:t>
+              <a:t>Agrégations Classiques</a:t>
             </a:r>
           </a:p>
           <a:p>
@@ -4147,7 +5150,7 @@
               <a:defRPr sz="1400"/>
             </a:pPr>
             <a:r>
-              <a:t>Hiérarchiques : données en arborescence.</a:t>
+              <a:t>COUNT(), AVG(), SUM(), MIN(), MAX().</a:t>
             </a:r>
           </a:p>
           <a:p>
@@ -4155,19 +5158,7 @@
               <a:defRPr sz="1400"/>
             </a:pPr>
             <a:r>
-              <a:t>Réseaux : arborescence avec raccourcis.</a:t>
-            </a:r>
-          </a:p>
-          <a:p>
-            <a:pPr>
-              <a:defRPr b="1" sz="1800">
-                <a:solidFill>
-                  <a:srgbClr val="282828"/>
-                </a:solidFill>
-              </a:defRPr>
-            </a:pPr>
-            <a:r>
-              <a:t>Années 1970 - Modèle Relationnel</a:t>
+              <a:t>Le GROUP BY : Réduction de dimensionnalité pour les KPIs.</a:t>
             </a:r>
           </a:p>
           <a:p>
@@ -4175,43 +5166,7 @@
               <a:defRPr sz="1400"/>
             </a:pPr>
             <a:r>
-              <a:t>1970 : Edgar F. Codd invente le modèle relationnel.</a:t>
-            </a:r>
-          </a:p>
-          <a:p>
-            <a:pPr lvl="1">
-              <a:defRPr sz="1400"/>
-            </a:pPr>
-            <a:r>
-              <a:t>Données organisées en tableaux liés entre eux. Langage SQL standardisé en 1974.</a:t>
-            </a:r>
-          </a:p>
-          <a:p>
-            <a:pPr>
-              <a:defRPr b="1" sz="1800">
-                <a:solidFill>
-                  <a:srgbClr val="ED1C24"/>
-                </a:solidFill>
-              </a:defRPr>
-            </a:pPr>
-            <a:r>
-              <a:t>Années 2000 - NoSQL</a:t>
-            </a:r>
-          </a:p>
-          <a:p>
-            <a:pPr lvl="1">
-              <a:defRPr sz="1400"/>
-            </a:pPr>
-            <a:r>
-              <a:t>Not Only SQL : Bases Clé/Valeur, Orientées Documents, Graphes.</a:t>
-            </a:r>
-          </a:p>
-          <a:p>
-            <a:pPr lvl="1">
-              <a:defRPr sz="1400"/>
-            </a:pPr>
-            <a:r>
-              <a:t>Pour le Big Data et la très haute disponibilité.</a:t>
+              <a:t>Le HAVING : Filtrer *après* l'agrégation (contrairement au WHERE).</a:t>
             </a:r>
           </a:p>
         </p:txBody>
@@ -4270,7 +5225,7 @@
             </a:r>
             <a:br/>
             <a:r>
-              <a:t>Frise chronologique des SGBD, mettant en avant l'apparition du Modèle Relationnel et du NoSQL.</a:t>
+              <a:t>Concept du GROUP BY: Des données brutes de différentes couleurs séparées dans des 'seaux' (Buckets) colorés.</a:t>
             </a:r>
           </a:p>
         </p:txBody>
@@ -4283,7 +5238,7 @@
 </p:sld>
 </file>
 
-<file path=ppt/slides/slide4.xml><?xml version="1.0" encoding="utf-8"?>
+<file path=ppt/slides/slide15.xml><?xml version="1.0" encoding="utf-8"?>
 <p:sld xmlns:a="http://schemas.openxmlformats.org/drawingml/2006/main" xmlns:p="http://schemas.openxmlformats.org/presentationml/2006/main" xmlns:r="http://schemas.openxmlformats.org/officeDocument/2006/relationships">
   <p:cSld>
     <p:spTree>
@@ -4341,7 +5296,7 @@
               </a:defRPr>
             </a:pPr>
             <a:r>
-              <a:t>3. La Notion de Transaction et l'ACIDité</a:t>
+              <a:t>13. Advanced SQL : CTEs &amp; Window Functions</a:t>
             </a:r>
           </a:p>
         </p:txBody>
@@ -4377,7 +5332,7 @@
               </a:defRPr>
             </a:pPr>
             <a:r>
-              <a:t>La Transaction</a:t>
+              <a:t>Common Table Expressions (CTEs)</a:t>
             </a:r>
           </a:p>
           <a:p>
@@ -4385,7 +5340,15 @@
               <a:defRPr sz="1400"/>
             </a:pPr>
             <a:r>
-              <a:t>Une séquence indivisible d'actions (ex: virement bancaire = débit + crédit).</a:t>
+              <a:t>La clause WITH : Remplace les sous-requêtes imbriquées illisibles.</a:t>
+            </a:r>
+          </a:p>
+          <a:p>
+            <a:pPr lvl="1">
+              <a:defRPr sz="1400"/>
+            </a:pPr>
+            <a:r>
+              <a:t>Rend le code SQL modulaire, lisible et maintenable.</a:t>
             </a:r>
           </a:p>
           <a:p>
@@ -4397,7 +5360,7 @@
               </a:defRPr>
             </a:pPr>
             <a:r>
-              <a:t>Les Principes ACID</a:t>
+              <a:t>Window Functions (Analyse Statistique)</a:t>
             </a:r>
           </a:p>
           <a:p>
@@ -4405,7 +5368,7 @@
               <a:defRPr sz="1400"/>
             </a:pPr>
             <a:r>
-              <a:t>Atomicité : La transaction est exécutée en entier ou annulée totalement.</a:t>
+              <a:t>Syntaxe : Fonction OVER (PARTITION BY ... ORDER BY ...).</a:t>
             </a:r>
           </a:p>
           <a:p>
@@ -4413,7 +5376,7 @@
               <a:defRPr sz="1400"/>
             </a:pPr>
             <a:r>
-              <a:t>Cohérence : La base passe d'un état valide à un autre état valide.</a:t>
+              <a:t>Calculs complexes (Rangs, Totaux cumulés, Moyennes mobiles) *sans* écraser le niveau de détail des lignes.</a:t>
             </a:r>
           </a:p>
           <a:p>
@@ -4421,15 +5384,7 @@
               <a:defRPr sz="1400"/>
             </a:pPr>
             <a:r>
-              <a:t>Isolation : Deux transactions simultanées n'interfèrent pas.</a:t>
-            </a:r>
-          </a:p>
-          <a:p>
-            <a:pPr lvl="1">
-              <a:defRPr sz="1400"/>
-            </a:pPr>
-            <a:r>
-              <a:t>Durabilité : Une transaction validée survit aux pannes système.</a:t>
+              <a:t>Fonctions analytiques clés : ROW_NUMBER(), RANK(), LAG(), LEAD().</a:t>
             </a:r>
           </a:p>
         </p:txBody>
@@ -4488,7 +5443,7 @@
             </a:r>
             <a:br/>
             <a:r>
-              <a:t>Icône d'un coffre-fort avec les 4 piliers de l'ACID.</a:t>
+              <a:t>Comparatif visuel : GROUP BY (écrase les lignes) vs OVER (maintient les lignes d'origine mais ajoute une colonne de calcul).</a:t>
             </a:r>
           </a:p>
         </p:txBody>
@@ -4501,7 +5456,7 @@
 </p:sld>
 </file>
 
-<file path=ppt/slides/slide5.xml><?xml version="1.0" encoding="utf-8"?>
+<file path=ppt/slides/slide2.xml><?xml version="1.0" encoding="utf-8"?>
 <p:sld xmlns:a="http://schemas.openxmlformats.org/drawingml/2006/main" xmlns:p="http://schemas.openxmlformats.org/presentationml/2006/main" xmlns:r="http://schemas.openxmlformats.org/officeDocument/2006/relationships">
   <p:cSld>
     <p:spTree>
@@ -4559,7 +5514,7 @@
               </a:defRPr>
             </a:pPr>
             <a:r>
-              <a:t>4. Le Modèle Relationnel : Fondements</a:t>
+              <a:t>1. Les Fondations de l'Ingénierie de Données</a:t>
             </a:r>
           </a:p>
         </p:txBody>
@@ -4595,7 +5550,7 @@
               </a:defRPr>
             </a:pPr>
             <a:r>
-              <a:t>Relations (Tables)</a:t>
+              <a:t>Au-delà du Tableur</a:t>
             </a:r>
           </a:p>
           <a:p>
@@ -4603,7 +5558,7 @@
               <a:defRPr sz="1400"/>
             </a:pPr>
             <a:r>
-              <a:t>L'information est stockée dans des tables constituées de colonnes (attributs) et de lignes (enregistrements).</a:t>
+              <a:t>Les bases de données séparent le stockage physique de la logique applicative.</a:t>
             </a:r>
           </a:p>
           <a:p>
@@ -4611,19 +5566,19 @@
               <a:defRPr sz="1400"/>
             </a:pPr>
             <a:r>
-              <a:t>Chaque colonne possède un domaine de valeurs précis (type, longueur, contraintes).</a:t>
+              <a:t>Objectif : Indépendance physique et logique des données.</a:t>
             </a:r>
           </a:p>
           <a:p>
             <a:pPr>
               <a:defRPr b="1" sz="1800">
                 <a:solidFill>
-                  <a:srgbClr val="ED1C24"/>
-                </a:solidFill>
-              </a:defRPr>
-            </a:pPr>
-            <a:r>
-              <a:t>Le Système de Clés</a:t>
+                  <a:srgbClr val="282828"/>
+                </a:solidFill>
+              </a:defRPr>
+            </a:pPr>
+            <a:r>
+              <a:t>Le Rôle du SGBDR (RDBMS)</a:t>
             </a:r>
           </a:p>
           <a:p>
@@ -4631,7 +5586,7 @@
               <a:defRPr sz="1400"/>
             </a:pPr>
             <a:r>
-              <a:t>Clé Primaire : Identifiant unique d'une ligne dans une table.</a:t>
+              <a:t>Le SGBDR n'est pas qu'un espace de stockage, c'est un moteur de règles.</a:t>
             </a:r>
           </a:p>
           <a:p>
@@ -4639,7 +5594,15 @@
               <a:defRPr sz="1400"/>
             </a:pPr>
             <a:r>
-              <a:t>Clé Étrangère : Colonne pointant vers la clé primaire d'une autre table, créant le lien.</a:t>
+              <a:t>Gestion stricte de la concurrence (verrous, isolation).</a:t>
+            </a:r>
+          </a:p>
+          <a:p>
+            <a:pPr lvl="1">
+              <a:defRPr sz="1400"/>
+            </a:pPr>
+            <a:r>
+              <a:t>Gestion de la reprise sur panne (Write-Ahead Logging).</a:t>
             </a:r>
           </a:p>
         </p:txBody>
@@ -4698,7 +5661,7 @@
             </a:r>
             <a:br/>
             <a:r>
-              <a:t>Illustration de deux tables (Ville et Personne). Un rayon laser relie la Clé Primaire 'Code_Ville' à la Clé Étrangère de la table Personne.</a:t>
+              <a:t>Architecture Client-Serveur: Couche Applicative -&gt; Moteur SGBD (Optimiseur de requêtes) -&gt; Stockage Disque.</a:t>
             </a:r>
           </a:p>
         </p:txBody>
@@ -4711,7 +5674,7 @@
 </p:sld>
 </file>
 
-<file path=ppt/slides/slide6.xml><?xml version="1.0" encoding="utf-8"?>
+<file path=ppt/slides/slide3.xml><?xml version="1.0" encoding="utf-8"?>
 <p:sld xmlns:a="http://schemas.openxmlformats.org/drawingml/2006/main" xmlns:p="http://schemas.openxmlformats.org/presentationml/2006/main" xmlns:r="http://schemas.openxmlformats.org/officeDocument/2006/relationships">
   <p:cSld>
     <p:spTree>
@@ -4769,7 +5732,7 @@
               </a:defRPr>
             </a:pPr>
             <a:r>
-              <a:t>5. Associations et Cardinalités</a:t>
+              <a:t>2. Les Différents Types de SGBD (Historique)</a:t>
             </a:r>
           </a:p>
         </p:txBody>
@@ -4805,7 +5768,7 @@
               </a:defRPr>
             </a:pPr>
             <a:r>
-              <a:t>Types de Liens</a:t>
+              <a:t>Années 1960</a:t>
             </a:r>
           </a:p>
           <a:p>
@@ -4813,7 +5776,7 @@
               <a:defRPr sz="1400"/>
             </a:pPr>
             <a:r>
-              <a:t>1-1 : Un pays a une seule capitale.</a:t>
+              <a:t>Hiérarchiques : données en arborescence.</a:t>
             </a:r>
           </a:p>
           <a:p>
@@ -4821,19 +5784,19 @@
               <a:defRPr sz="1400"/>
             </a:pPr>
             <a:r>
-              <a:t>1-N : Un pays possède plusieurs villes, une ville appartient à un seul pays.</a:t>
+              <a:t>Réseaux : arborescence avec raccourcis.</a:t>
             </a:r>
           </a:p>
           <a:p>
             <a:pPr>
               <a:defRPr b="1" sz="1800">
                 <a:solidFill>
-                  <a:srgbClr val="ED1C24"/>
-                </a:solidFill>
-              </a:defRPr>
-            </a:pPr>
-            <a:r>
-              <a:t>Le Cas Complexe : Plusieurs-à-Plusieurs (N-M)</a:t>
+                  <a:srgbClr val="282828"/>
+                </a:solidFill>
+              </a:defRPr>
+            </a:pPr>
+            <a:r>
+              <a:t>Années 1970 - Modèle Relationnel</a:t>
             </a:r>
           </a:p>
           <a:p>
@@ -4841,7 +5804,7 @@
               <a:defRPr sz="1400"/>
             </a:pPr>
             <a:r>
-              <a:t>Ex: Une personne travaille dans plusieurs entreprises, une entreprise emploie plusieurs personnes.</a:t>
+              <a:t>1970 : Edgar F. Codd invente le modèle relationnel.</a:t>
             </a:r>
           </a:p>
           <a:p>
@@ -4849,7 +5812,35 @@
               <a:defRPr sz="1400"/>
             </a:pPr>
             <a:r>
-              <a:t>Solution : Créer une 'Table d'Association' (ex: Travail) contenant les clés étrangères des deux tables.</a:t>
+              <a:t>Données organisées en tableaux liés entre eux. Langage SQL standardisé en 1974.</a:t>
+            </a:r>
+          </a:p>
+          <a:p>
+            <a:pPr>
+              <a:defRPr b="1" sz="1800">
+                <a:solidFill>
+                  <a:srgbClr val="ED1C24"/>
+                </a:solidFill>
+              </a:defRPr>
+            </a:pPr>
+            <a:r>
+              <a:t>Années 2000 - NoSQL</a:t>
+            </a:r>
+          </a:p>
+          <a:p>
+            <a:pPr lvl="1">
+              <a:defRPr sz="1400"/>
+            </a:pPr>
+            <a:r>
+              <a:t>Not Only SQL : Bases Clé/Valeur, Orientées Documents, Graphes.</a:t>
+            </a:r>
+          </a:p>
+          <a:p>
+            <a:pPr lvl="1">
+              <a:defRPr sz="1400"/>
+            </a:pPr>
+            <a:r>
+              <a:t>Pour le Big Data et la très haute disponibilité.</a:t>
             </a:r>
           </a:p>
         </p:txBody>
@@ -4908,7 +5899,7 @@
             </a:r>
             <a:br/>
             <a:r>
-              <a:t>Schéma expliquant la résolution d'une relation N-M par une table intermédiaire.</a:t>
+              <a:t>Frise chronologique des SGBD, mettant en avant l'apparition du Modèle Relationnel et du NoSQL.</a:t>
             </a:r>
           </a:p>
         </p:txBody>
@@ -4921,7 +5912,7 @@
 </p:sld>
 </file>
 
-<file path=ppt/slides/slide7.xml><?xml version="1.0" encoding="utf-8"?>
+<file path=ppt/slides/slide4.xml><?xml version="1.0" encoding="utf-8"?>
 <p:sld xmlns:a="http://schemas.openxmlformats.org/drawingml/2006/main" xmlns:p="http://schemas.openxmlformats.org/presentationml/2006/main" xmlns:r="http://schemas.openxmlformats.org/officeDocument/2006/relationships">
   <p:cSld>
     <p:spTree>
@@ -4979,7 +5970,7 @@
               </a:defRPr>
             </a:pPr>
             <a:r>
-              <a:t>6. L'Algèbre Relationnelle</a:t>
+              <a:t>3. L'Architecture Transactionnelle : ACID</a:t>
             </a:r>
           </a:p>
         </p:txBody>
@@ -5015,7 +6006,7 @@
               </a:defRPr>
             </a:pPr>
             <a:r>
-              <a:t>Opérations sur 1 table</a:t>
+              <a:t>La Transaction de bout en bout</a:t>
             </a:r>
           </a:p>
           <a:p>
@@ -5023,7 +6014,19 @@
               <a:defRPr sz="1400"/>
             </a:pPr>
             <a:r>
-              <a:t>Sélection : Filtre les lignes selon une condition.</a:t>
+              <a:t>L'unité logique de traitement garantissant l'intégrité systémique.</a:t>
+            </a:r>
+          </a:p>
+          <a:p>
+            <a:pPr>
+              <a:defRPr b="1" sz="1800">
+                <a:solidFill>
+                  <a:srgbClr val="ED1C24"/>
+                </a:solidFill>
+              </a:defRPr>
+            </a:pPr>
+            <a:r>
+              <a:t>Les Principes Fondamentaux</a:t>
             </a:r>
           </a:p>
           <a:p>
@@ -5031,7 +6034,7 @@
               <a:defRPr sz="1400"/>
             </a:pPr>
             <a:r>
-              <a:t>Projection : Ne conserve que certaines colonnes.</a:t>
+              <a:t>Atomicité (All-or-Nothing) : Exécution complète ou Rollback total.</a:t>
             </a:r>
           </a:p>
           <a:p>
@@ -5039,19 +6042,7 @@
               <a:defRPr sz="1400"/>
             </a:pPr>
             <a:r>
-              <a:t>Renommage : Modifie le nom d'une colonne.</a:t>
-            </a:r>
-          </a:p>
-          <a:p>
-            <a:pPr>
-              <a:defRPr b="1" sz="1800">
-                <a:solidFill>
-                  <a:srgbClr val="ED1C24"/>
-                </a:solidFill>
-              </a:defRPr>
-            </a:pPr>
-            <a:r>
-              <a:t>Opérations sur 2 tables</a:t>
+              <a:t>Cohérence : Application stricte des contraintes (Constraints &amp; Triggers).</a:t>
             </a:r>
           </a:p>
           <a:p>
@@ -5059,7 +6050,7 @@
               <a:defRPr sz="1400"/>
             </a:pPr>
             <a:r>
-              <a:t>Produit Cartésien : Combine tous les éléments de deux tables.</a:t>
+              <a:t>Isolation : Prévention des lectures sales (Dirty Reads) via les niveaux d'isolation.</a:t>
             </a:r>
           </a:p>
           <a:p>
@@ -5067,7 +6058,7 @@
               <a:defRPr sz="1400"/>
             </a:pPr>
             <a:r>
-              <a:t>Jointure : Combine des éléments répondant à un critère de liaison.</a:t>
+              <a:t>Durabilité : Persistance garantie même en cas d'arrêt brutal (Crash).</a:t>
             </a:r>
           </a:p>
         </p:txBody>
@@ -5126,7 +6117,7 @@
             </a:r>
             <a:br/>
             <a:r>
-              <a:t>Infographie montrant le concept visuel de la Projection (colonnes verticales en surbrillance) et de la Sélection (lignes horizontales en surbrillance).</a:t>
+              <a:t>Icône d'un coffre-fort avec les 4 piliers de l'ACID. Indiquer 'Commit' et 'Rollback'.</a:t>
             </a:r>
           </a:p>
         </p:txBody>
@@ -5139,7 +6130,7 @@
 </p:sld>
 </file>
 
-<file path=ppt/slides/slide8.xml><?xml version="1.0" encoding="utf-8"?>
+<file path=ppt/slides/slide5.xml><?xml version="1.0" encoding="utf-8"?>
 <p:sld xmlns:a="http://schemas.openxmlformats.org/drawingml/2006/main" xmlns:p="http://schemas.openxmlformats.org/presentationml/2006/main" xmlns:r="http://schemas.openxmlformats.org/officeDocument/2006/relationships">
   <p:cSld>
     <p:spTree>
@@ -5197,7 +6188,7 @@
               </a:defRPr>
             </a:pPr>
             <a:r>
-              <a:t>7. Modélisation Conceptuelle avec UML</a:t>
+              <a:t>4. Le Modèle Relationnel : Fondements</a:t>
             </a:r>
           </a:p>
         </p:txBody>
@@ -5233,7 +6224,7 @@
               </a:defRPr>
             </a:pPr>
             <a:r>
-              <a:t>Diagramme de Classes UML</a:t>
+              <a:t>Relations (Tables)</a:t>
             </a:r>
           </a:p>
           <a:p>
@@ -5241,7 +6232,7 @@
               <a:defRPr sz="1400"/>
             </a:pPr>
             <a:r>
-              <a:t>Le nom de la relation en haut.</a:t>
+              <a:t>L'information est stockée dans des tables constituées de colonnes (attributs) et de lignes (enregistrements).</a:t>
             </a:r>
           </a:p>
           <a:p>
@@ -5249,7 +6240,19 @@
               <a:defRPr sz="1400"/>
             </a:pPr>
             <a:r>
-              <a:t>La liste des colonnes en bas : nom_colonne: type(longueur).</a:t>
+              <a:t>Chaque colonne possède un domaine de valeurs précis (type, longueur, contraintes).</a:t>
+            </a:r>
+          </a:p>
+          <a:p>
+            <a:pPr>
+              <a:defRPr b="1" sz="1800">
+                <a:solidFill>
+                  <a:srgbClr val="ED1C24"/>
+                </a:solidFill>
+              </a:defRPr>
+            </a:pPr>
+            <a:r>
+              <a:t>Le Système de Clés</a:t>
             </a:r>
           </a:p>
           <a:p>
@@ -5257,19 +6260,7 @@
               <a:defRPr sz="1400"/>
             </a:pPr>
             <a:r>
-              <a:t>Les Clés Primaires sont soulignées, les Clés Étrangères précédées d'un #.</a:t>
-            </a:r>
-          </a:p>
-          <a:p>
-            <a:pPr>
-              <a:defRPr b="1" sz="1800">
-                <a:solidFill>
-                  <a:srgbClr val="ED1C24"/>
-                </a:solidFill>
-              </a:defRPr>
-            </a:pPr>
-            <a:r>
-              <a:t>Agrégation et Composition</a:t>
+              <a:t>Clé Primaire : Identifiant unique d'une ligne dans une table.</a:t>
             </a:r>
           </a:p>
           <a:p>
@@ -5277,15 +6268,7 @@
               <a:defRPr sz="1400"/>
             </a:pPr>
             <a:r>
-              <a:t>Agrégation : Lien simple (ex: une maison est une agrégation de murs).</a:t>
-            </a:r>
-          </a:p>
-          <a:p>
-            <a:pPr lvl="1">
-              <a:defRPr sz="1400"/>
-            </a:pPr>
-            <a:r>
-              <a:t>Composition : Agrégation forte, la destruction du tout détruit la partie (ex: école et cycles scolaires).</a:t>
+              <a:t>Clé Étrangère : Colonne pointant vers la clé primaire d'une autre table, créant le lien.</a:t>
             </a:r>
           </a:p>
         </p:txBody>
@@ -5344,7 +6327,7 @@
             </a:r>
             <a:br/>
             <a:r>
-              <a:t>Exemple de formalisme UML strict avec une table d'association.</a:t>
+              <a:t>Illustration de deux tables (Ville et Personne). Un rayon laser relie la Clé Primaire 'Code_Ville' à la Clé Étrangère de la table Personne.</a:t>
             </a:r>
           </a:p>
         </p:txBody>
@@ -5357,7 +6340,7 @@
 </p:sld>
 </file>
 
-<file path=ppt/slides/slide9.xml><?xml version="1.0" encoding="utf-8"?>
+<file path=ppt/slides/slide6.xml><?xml version="1.0" encoding="utf-8"?>
 <p:sld xmlns:a="http://schemas.openxmlformats.org/drawingml/2006/main" xmlns:p="http://schemas.openxmlformats.org/presentationml/2006/main" xmlns:r="http://schemas.openxmlformats.org/officeDocument/2006/relationships">
   <p:cSld>
     <p:spTree>
@@ -5415,7 +6398,7 @@
               </a:defRPr>
             </a:pPr>
             <a:r>
-              <a:t>8. Le Langage SQL : Définition des Données</a:t>
+              <a:t>5. Associations et Cardinalités</a:t>
             </a:r>
           </a:p>
         </p:txBody>
@@ -5451,7 +6434,7 @@
               </a:defRPr>
             </a:pPr>
             <a:r>
-              <a:t>Architecture Client-Serveur</a:t>
+              <a:t>Types de Liens</a:t>
             </a:r>
           </a:p>
           <a:p>
@@ -5459,7 +6442,15 @@
               <a:defRPr sz="1400"/>
             </a:pPr>
             <a:r>
-              <a:t>Le client (ex: DBeaver) envoie des requêtes SQL au serveur (ex: PostgreSQL).</a:t>
+              <a:t>1-1 : Un pays a une seule capitale.</a:t>
+            </a:r>
+          </a:p>
+          <a:p>
+            <a:pPr lvl="1">
+              <a:defRPr sz="1400"/>
+            </a:pPr>
+            <a:r>
+              <a:t>1-N : Un pays possède plusieurs villes, une ville appartient à un seul pays.</a:t>
             </a:r>
           </a:p>
           <a:p>
@@ -5471,7 +6462,7 @@
               </a:defRPr>
             </a:pPr>
             <a:r>
-              <a:t>Création de Tables (DDL)</a:t>
+              <a:t>Le Cas Complexe : Plusieurs-à-Plusieurs (N-M)</a:t>
             </a:r>
           </a:p>
           <a:p>
@@ -5479,7 +6470,7 @@
               <a:defRPr sz="1400"/>
             </a:pPr>
             <a:r>
-              <a:t>Syntaxe : CREATE TABLE nom (colonne1 type, colonne2 type);</a:t>
+              <a:t>Ex: Une personne travaille dans plusieurs entreprises, une entreprise emploie plusieurs personnes.</a:t>
             </a:r>
           </a:p>
           <a:p>
@@ -5487,35 +6478,7 @@
               <a:defRPr sz="1400"/>
             </a:pPr>
             <a:r>
-              <a:t>Contraintes : NOT NULL, PRIMARY KEY, UNIQUE, CHECK(condition).</a:t>
-            </a:r>
-          </a:p>
-          <a:p>
-            <a:pPr>
-              <a:defRPr b="1" sz="1800">
-                <a:solidFill>
-                  <a:srgbClr val="282828"/>
-                </a:solidFill>
-              </a:defRPr>
-            </a:pPr>
-            <a:r>
-              <a:t>Modification</a:t>
-            </a:r>
-          </a:p>
-          <a:p>
-            <a:pPr lvl="1">
-              <a:defRPr sz="1400"/>
-            </a:pPr>
-            <a:r>
-              <a:t>ALTER TABLE : Ajouter, supprimer des colonnes ou des contraintes.</a:t>
-            </a:r>
-          </a:p>
-          <a:p>
-            <a:pPr lvl="1">
-              <a:defRPr sz="1400"/>
-            </a:pPr>
-            <a:r>
-              <a:t>DROP TABLE : Supprimer une table.</a:t>
+              <a:t>Solution : Créer une 'Table d'Association' (ex: Travail) contenant les clés étrangères des deux tables.</a:t>
             </a:r>
           </a:p>
         </p:txBody>
@@ -5574,7 +6537,677 @@
             </a:r>
             <a:br/>
             <a:r>
-              <a:t>Capture d'écran de l'interface DBeaver connectée à une base PostgreSQL.</a:t>
+              <a:t>Schéma expliquant la résolution d'une relation N-M par une table de jonction.</a:t>
+            </a:r>
+          </a:p>
+        </p:txBody>
+      </p:sp>
+    </p:spTree>
+  </p:cSld>
+  <p:clrMapOvr>
+    <a:masterClrMapping/>
+  </p:clrMapOvr>
+</p:sld>
+</file>
+
+<file path=ppt/slides/slide7.xml><?xml version="1.0" encoding="utf-8"?>
+<p:sld xmlns:a="http://schemas.openxmlformats.org/drawingml/2006/main" xmlns:p="http://schemas.openxmlformats.org/presentationml/2006/main" xmlns:r="http://schemas.openxmlformats.org/officeDocument/2006/relationships">
+  <p:cSld>
+    <p:spTree>
+      <p:nvGrpSpPr>
+        <p:cNvPr id="1" name=""/>
+        <p:cNvGrpSpPr/>
+        <p:nvPr/>
+      </p:nvGrpSpPr>
+      <p:grpSpPr/>
+      <p:sp>
+        <p:nvSpPr>
+          <p:cNvPr id="2" name="Title 1"/>
+          <p:cNvSpPr>
+            <a:spLocks noGrp="1"/>
+          </p:cNvSpPr>
+          <p:nvPr>
+            <p:ph type="title"/>
+          </p:nvPr>
+        </p:nvSpPr>
+        <p:spPr/>
+        <p:txBody>
+          <a:bodyPr/>
+          <a:lstStyle/>
+          <a:p/>
+        </p:txBody>
+      </p:sp>
+      <p:sp>
+        <p:nvSpPr>
+          <p:cNvPr id="3" name="TextBox 2"/>
+          <p:cNvSpPr txBox="1"/>
+          <p:nvPr/>
+        </p:nvSpPr>
+        <p:spPr>
+          <a:xfrm>
+            <a:off x="457200" y="457200"/>
+            <a:ext cx="8229600" cy="914400"/>
+          </a:xfrm>
+          <a:prstGeom prst="rect">
+            <a:avLst/>
+          </a:prstGeom>
+          <a:noFill/>
+        </p:spPr>
+        <p:txBody>
+          <a:bodyPr wrap="none">
+            <a:spAutoFit/>
+          </a:bodyPr>
+          <a:lstStyle/>
+          <a:p>
+            <a:pPr algn="l">
+              <a:defRPr sz="2600" b="1">
+                <a:solidFill>
+                  <a:srgbClr val="ED1C24"/>
+                </a:solidFill>
+                <a:latin typeface="Calibri"/>
+              </a:defRPr>
+            </a:pPr>
+            <a:r>
+              <a:t>6. Théorie de l'Architecture : La Normalisation</a:t>
+            </a:r>
+          </a:p>
+        </p:txBody>
+      </p:sp>
+      <p:sp>
+        <p:nvSpPr>
+          <p:cNvPr id="4" name="TextBox 3"/>
+          <p:cNvSpPr txBox="1"/>
+          <p:nvPr/>
+        </p:nvSpPr>
+        <p:spPr>
+          <a:xfrm>
+            <a:off x="457200" y="1371600"/>
+            <a:ext cx="4572000" cy="4572000"/>
+          </a:xfrm>
+          <a:prstGeom prst="rect">
+            <a:avLst/>
+          </a:prstGeom>
+          <a:noFill/>
+        </p:spPr>
+        <p:txBody>
+          <a:bodyPr wrap="square">
+            <a:spAutoFit/>
+          </a:bodyPr>
+          <a:lstStyle/>
+          <a:p/>
+          <a:p>
+            <a:pPr>
+              <a:defRPr b="1" sz="1800">
+                <a:solidFill>
+                  <a:srgbClr val="282828"/>
+                </a:solidFill>
+              </a:defRPr>
+            </a:pPr>
+            <a:r>
+              <a:t>Pourquoi normaliser ?</a:t>
+            </a:r>
+          </a:p>
+          <a:p>
+            <a:pPr lvl="1">
+              <a:defRPr sz="1400"/>
+            </a:pPr>
+            <a:r>
+              <a:t>Éviter les anomalies d'insertion, de mise à jour et de suppression.</a:t>
+            </a:r>
+          </a:p>
+          <a:p>
+            <a:pPr lvl="1">
+              <a:defRPr sz="1400"/>
+            </a:pPr>
+            <a:r>
+              <a:t>Éliminer la redondance des données pour garantir une source unique de vérité.</a:t>
+            </a:r>
+          </a:p>
+          <a:p>
+            <a:pPr>
+              <a:defRPr b="1" sz="1800">
+                <a:solidFill>
+                  <a:srgbClr val="ED1C24"/>
+                </a:solidFill>
+              </a:defRPr>
+            </a:pPr>
+            <a:r>
+              <a:t>Les Formes Normales (Normal Forms)</a:t>
+            </a:r>
+          </a:p>
+          <a:p>
+            <a:pPr lvl="1">
+              <a:defRPr sz="1400"/>
+            </a:pPr>
+            <a:r>
+              <a:t>1NF : Valeurs atomiques (pas de listes dans une colonne).</a:t>
+            </a:r>
+          </a:p>
+          <a:p>
+            <a:pPr lvl="1">
+              <a:defRPr sz="1400"/>
+            </a:pPr>
+            <a:r>
+              <a:t>2NF : 1NF + Tout attribut non clé dépend de la totalité de la clé primaire.</a:t>
+            </a:r>
+          </a:p>
+          <a:p>
+            <a:pPr lvl="1">
+              <a:defRPr sz="1400"/>
+            </a:pPr>
+            <a:r>
+              <a:t>3NF : 2NF + Pas de dépendance transitive (un attribut non clé ne doit pas dépendre d'un autre attribut non clé).</a:t>
+            </a:r>
+          </a:p>
+          <a:p>
+            <a:pPr lvl="1">
+              <a:defRPr sz="1400"/>
+            </a:pPr>
+            <a:r>
+              <a:t>BCNF (Boyce-Codd) : Version stricte de la 3NF.</a:t>
+            </a:r>
+          </a:p>
+        </p:txBody>
+      </p:sp>
+      <p:sp>
+        <p:nvSpPr>
+          <p:cNvPr id="5" name="Rectangle 4"/>
+          <p:cNvSpPr/>
+          <p:nvPr/>
+        </p:nvSpPr>
+        <p:spPr>
+          <a:xfrm>
+            <a:off x="5486400" y="1371600"/>
+            <a:ext cx="3200400" cy="4572000"/>
+          </a:xfrm>
+          <a:prstGeom prst="rect">
+            <a:avLst/>
+          </a:prstGeom>
+          <a:solidFill>
+            <a:srgbClr val="FFFFFF"/>
+          </a:solidFill>
+          <a:ln w="25400">
+            <a:solidFill>
+              <a:srgbClr val="ED1C24"/>
+            </a:solidFill>
+          </a:ln>
+        </p:spPr>
+        <p:style>
+          <a:lnRef idx="1">
+            <a:schemeClr val="accent1"/>
+          </a:lnRef>
+          <a:fillRef idx="3">
+            <a:schemeClr val="accent1"/>
+          </a:fillRef>
+          <a:effectRef idx="2">
+            <a:schemeClr val="accent1"/>
+          </a:effectRef>
+          <a:fontRef idx="minor">
+            <a:schemeClr val="lt1"/>
+          </a:fontRef>
+        </p:style>
+        <p:txBody>
+          <a:bodyPr rtlCol="0" anchor="ctr"/>
+          <a:lstStyle/>
+          <a:p>
+            <a:pPr algn="ctr">
+              <a:defRPr sz="1200" b="0">
+                <a:solidFill>
+                  <a:srgbClr val="282828"/>
+                </a:solidFill>
+                <a:latin typeface="Calibri"/>
+              </a:defRPr>
+            </a:pPr>
+            <a:r>
+              <a:t>[VISUEL KADEA]</a:t>
+            </a:r>
+            <a:br/>
+            <a:r>
+              <a:t>Tableau montrant une donnée 'dénormalisée' se divisant proprement en trois tables normalisées (1NF -&gt; 3NF).</a:t>
+            </a:r>
+          </a:p>
+        </p:txBody>
+      </p:sp>
+    </p:spTree>
+  </p:cSld>
+  <p:clrMapOvr>
+    <a:masterClrMapping/>
+  </p:clrMapOvr>
+</p:sld>
+</file>
+
+<file path=ppt/slides/slide8.xml><?xml version="1.0" encoding="utf-8"?>
+<p:sld xmlns:a="http://schemas.openxmlformats.org/drawingml/2006/main" xmlns:p="http://schemas.openxmlformats.org/presentationml/2006/main" xmlns:r="http://schemas.openxmlformats.org/officeDocument/2006/relationships">
+  <p:cSld>
+    <p:spTree>
+      <p:nvGrpSpPr>
+        <p:cNvPr id="1" name=""/>
+        <p:cNvGrpSpPr/>
+        <p:nvPr/>
+      </p:nvGrpSpPr>
+      <p:grpSpPr/>
+      <p:sp>
+        <p:nvSpPr>
+          <p:cNvPr id="2" name="Title 1"/>
+          <p:cNvSpPr>
+            <a:spLocks noGrp="1"/>
+          </p:cNvSpPr>
+          <p:nvPr>
+            <p:ph type="title"/>
+          </p:nvPr>
+        </p:nvSpPr>
+        <p:spPr/>
+        <p:txBody>
+          <a:bodyPr/>
+          <a:lstStyle/>
+          <a:p/>
+        </p:txBody>
+      </p:sp>
+      <p:sp>
+        <p:nvSpPr>
+          <p:cNvPr id="3" name="TextBox 2"/>
+          <p:cNvSpPr txBox="1"/>
+          <p:nvPr/>
+        </p:nvSpPr>
+        <p:spPr>
+          <a:xfrm>
+            <a:off x="457200" y="457200"/>
+            <a:ext cx="8229600" cy="914400"/>
+          </a:xfrm>
+          <a:prstGeom prst="rect">
+            <a:avLst/>
+          </a:prstGeom>
+          <a:noFill/>
+        </p:spPr>
+        <p:txBody>
+          <a:bodyPr wrap="none">
+            <a:spAutoFit/>
+          </a:bodyPr>
+          <a:lstStyle/>
+          <a:p>
+            <a:pPr algn="l">
+              <a:defRPr sz="2600" b="1">
+                <a:solidFill>
+                  <a:srgbClr val="ED1C24"/>
+                </a:solidFill>
+                <a:latin typeface="Calibri"/>
+              </a:defRPr>
+            </a:pPr>
+            <a:r>
+              <a:t>7. Performance : Indexation et Plans d'Exécution</a:t>
+            </a:r>
+          </a:p>
+        </p:txBody>
+      </p:sp>
+      <p:sp>
+        <p:nvSpPr>
+          <p:cNvPr id="4" name="TextBox 3"/>
+          <p:cNvSpPr txBox="1"/>
+          <p:nvPr/>
+        </p:nvSpPr>
+        <p:spPr>
+          <a:xfrm>
+            <a:off x="457200" y="1371600"/>
+            <a:ext cx="4572000" cy="4572000"/>
+          </a:xfrm>
+          <a:prstGeom prst="rect">
+            <a:avLst/>
+          </a:prstGeom>
+          <a:noFill/>
+        </p:spPr>
+        <p:txBody>
+          <a:bodyPr wrap="square">
+            <a:spAutoFit/>
+          </a:bodyPr>
+          <a:lstStyle/>
+          <a:p/>
+          <a:p>
+            <a:pPr>
+              <a:defRPr b="1" sz="1800">
+                <a:solidFill>
+                  <a:srgbClr val="282828"/>
+                </a:solidFill>
+              </a:defRPr>
+            </a:pPr>
+            <a:r>
+              <a:t>Les Mécanismes d'Indexation</a:t>
+            </a:r>
+          </a:p>
+          <a:p>
+            <a:pPr lvl="1">
+              <a:defRPr sz="1400"/>
+            </a:pPr>
+            <a:r>
+              <a:t>Un index accélère la lecture mais ralentit l'écriture (INSERT/UPDATE).</a:t>
+            </a:r>
+          </a:p>
+          <a:p>
+            <a:pPr lvl="1">
+              <a:defRPr sz="1400"/>
+            </a:pPr>
+            <a:r>
+              <a:t>Arbres B-Tree (Balanced Tree) : Standard pour les recherches de plages.</a:t>
+            </a:r>
+          </a:p>
+          <a:p>
+            <a:pPr lvl="1">
+              <a:defRPr sz="1400"/>
+            </a:pPr>
+            <a:r>
+              <a:t>Index Hash : Optimisés pour les correspondances exactes.</a:t>
+            </a:r>
+          </a:p>
+          <a:p>
+            <a:pPr>
+              <a:defRPr b="1" sz="1800">
+                <a:solidFill>
+                  <a:srgbClr val="ED1C24"/>
+                </a:solidFill>
+              </a:defRPr>
+            </a:pPr>
+            <a:r>
+              <a:t>Query Execution Plan (EXPLAIN)</a:t>
+            </a:r>
+          </a:p>
+          <a:p>
+            <a:pPr lvl="1">
+              <a:defRPr sz="1400"/>
+            </a:pPr>
+            <a:r>
+              <a:t>L'optimiseur (Query Planner) décide comment lire les données.</a:t>
+            </a:r>
+          </a:p>
+          <a:p>
+            <a:pPr lvl="1">
+              <a:defRPr sz="1400"/>
+            </a:pPr>
+            <a:r>
+              <a:t>Full Table Scan : Lecture séquentielle (très coûteuse).</a:t>
+            </a:r>
+          </a:p>
+          <a:p>
+            <a:pPr lvl="1">
+              <a:defRPr sz="1400"/>
+            </a:pPr>
+            <a:r>
+              <a:t>Index Seek / Scan : Accès direct via l'index O(log N).</a:t>
+            </a:r>
+          </a:p>
+        </p:txBody>
+      </p:sp>
+      <p:sp>
+        <p:nvSpPr>
+          <p:cNvPr id="5" name="Rectangle 4"/>
+          <p:cNvSpPr/>
+          <p:nvPr/>
+        </p:nvSpPr>
+        <p:spPr>
+          <a:xfrm>
+            <a:off x="5486400" y="1371600"/>
+            <a:ext cx="3200400" cy="4572000"/>
+          </a:xfrm>
+          <a:prstGeom prst="rect">
+            <a:avLst/>
+          </a:prstGeom>
+          <a:solidFill>
+            <a:srgbClr val="FFFFFF"/>
+          </a:solidFill>
+          <a:ln w="25400">
+            <a:solidFill>
+              <a:srgbClr val="ED1C24"/>
+            </a:solidFill>
+          </a:ln>
+        </p:spPr>
+        <p:style>
+          <a:lnRef idx="1">
+            <a:schemeClr val="accent1"/>
+          </a:lnRef>
+          <a:fillRef idx="3">
+            <a:schemeClr val="accent1"/>
+          </a:fillRef>
+          <a:effectRef idx="2">
+            <a:schemeClr val="accent1"/>
+          </a:effectRef>
+          <a:fontRef idx="minor">
+            <a:schemeClr val="lt1"/>
+          </a:fontRef>
+        </p:style>
+        <p:txBody>
+          <a:bodyPr rtlCol="0" anchor="ctr"/>
+          <a:lstStyle/>
+          <a:p>
+            <a:pPr algn="ctr">
+              <a:defRPr sz="1200" b="0">
+                <a:solidFill>
+                  <a:srgbClr val="282828"/>
+                </a:solidFill>
+                <a:latin typeface="Calibri"/>
+              </a:defRPr>
+            </a:pPr>
+            <a:r>
+              <a:t>[VISUEL KADEA]</a:t>
+            </a:r>
+            <a:br/>
+            <a:r>
+              <a:t>Arbre B-Tree inversé cherchant la valeur 42, contre un tableau scanné ligne par ligne.</a:t>
+            </a:r>
+          </a:p>
+        </p:txBody>
+      </p:sp>
+    </p:spTree>
+  </p:cSld>
+  <p:clrMapOvr>
+    <a:masterClrMapping/>
+  </p:clrMapOvr>
+</p:sld>
+</file>
+
+<file path=ppt/slides/slide9.xml><?xml version="1.0" encoding="utf-8"?>
+<p:sld xmlns:a="http://schemas.openxmlformats.org/drawingml/2006/main" xmlns:p="http://schemas.openxmlformats.org/presentationml/2006/main" xmlns:r="http://schemas.openxmlformats.org/officeDocument/2006/relationships">
+  <p:cSld>
+    <p:spTree>
+      <p:nvGrpSpPr>
+        <p:cNvPr id="1" name=""/>
+        <p:cNvGrpSpPr/>
+        <p:nvPr/>
+      </p:nvGrpSpPr>
+      <p:grpSpPr/>
+      <p:sp>
+        <p:nvSpPr>
+          <p:cNvPr id="2" name="Title 1"/>
+          <p:cNvSpPr>
+            <a:spLocks noGrp="1"/>
+          </p:cNvSpPr>
+          <p:nvPr>
+            <p:ph type="title"/>
+          </p:nvPr>
+        </p:nvSpPr>
+        <p:spPr/>
+        <p:txBody>
+          <a:bodyPr/>
+          <a:lstStyle/>
+          <a:p/>
+        </p:txBody>
+      </p:sp>
+      <p:sp>
+        <p:nvSpPr>
+          <p:cNvPr id="3" name="TextBox 2"/>
+          <p:cNvSpPr txBox="1"/>
+          <p:nvPr/>
+        </p:nvSpPr>
+        <p:spPr>
+          <a:xfrm>
+            <a:off x="457200" y="457200"/>
+            <a:ext cx="8229600" cy="914400"/>
+          </a:xfrm>
+          <a:prstGeom prst="rect">
+            <a:avLst/>
+          </a:prstGeom>
+          <a:noFill/>
+        </p:spPr>
+        <p:txBody>
+          <a:bodyPr wrap="none">
+            <a:spAutoFit/>
+          </a:bodyPr>
+          <a:lstStyle/>
+          <a:p>
+            <a:pPr algn="l">
+              <a:defRPr sz="2600" b="1">
+                <a:solidFill>
+                  <a:srgbClr val="ED1C24"/>
+                </a:solidFill>
+                <a:latin typeface="Calibri"/>
+              </a:defRPr>
+            </a:pPr>
+            <a:r>
+              <a:t>6. L'Algèbre Relationnelle</a:t>
+            </a:r>
+          </a:p>
+        </p:txBody>
+      </p:sp>
+      <p:sp>
+        <p:nvSpPr>
+          <p:cNvPr id="4" name="TextBox 3"/>
+          <p:cNvSpPr txBox="1"/>
+          <p:nvPr/>
+        </p:nvSpPr>
+        <p:spPr>
+          <a:xfrm>
+            <a:off x="457200" y="1371600"/>
+            <a:ext cx="4572000" cy="4572000"/>
+          </a:xfrm>
+          <a:prstGeom prst="rect">
+            <a:avLst/>
+          </a:prstGeom>
+          <a:noFill/>
+        </p:spPr>
+        <p:txBody>
+          <a:bodyPr wrap="square">
+            <a:spAutoFit/>
+          </a:bodyPr>
+          <a:lstStyle/>
+          <a:p/>
+          <a:p>
+            <a:pPr>
+              <a:defRPr b="1" sz="1800">
+                <a:solidFill>
+                  <a:srgbClr val="282828"/>
+                </a:solidFill>
+              </a:defRPr>
+            </a:pPr>
+            <a:r>
+              <a:t>Opérations sur 1 table</a:t>
+            </a:r>
+          </a:p>
+          <a:p>
+            <a:pPr lvl="1">
+              <a:defRPr sz="1400"/>
+            </a:pPr>
+            <a:r>
+              <a:t>Sélection : Filtre les lignes selon une condition.</a:t>
+            </a:r>
+          </a:p>
+          <a:p>
+            <a:pPr lvl="1">
+              <a:defRPr sz="1400"/>
+            </a:pPr>
+            <a:r>
+              <a:t>Projection : Ne conserve que certaines colonnes.</a:t>
+            </a:r>
+          </a:p>
+          <a:p>
+            <a:pPr lvl="1">
+              <a:defRPr sz="1400"/>
+            </a:pPr>
+            <a:r>
+              <a:t>Renommage : Modifie le nom d'une colonne.</a:t>
+            </a:r>
+          </a:p>
+          <a:p>
+            <a:pPr>
+              <a:defRPr b="1" sz="1800">
+                <a:solidFill>
+                  <a:srgbClr val="ED1C24"/>
+                </a:solidFill>
+              </a:defRPr>
+            </a:pPr>
+            <a:r>
+              <a:t>Opérations sur 2 tables</a:t>
+            </a:r>
+          </a:p>
+          <a:p>
+            <a:pPr lvl="1">
+              <a:defRPr sz="1400"/>
+            </a:pPr>
+            <a:r>
+              <a:t>Produit Cartésien : Combine tous les éléments de deux tables.</a:t>
+            </a:r>
+          </a:p>
+          <a:p>
+            <a:pPr lvl="1">
+              <a:defRPr sz="1400"/>
+            </a:pPr>
+            <a:r>
+              <a:t>Jointure : Combine des éléments répondant à un critère de liaison.</a:t>
+            </a:r>
+          </a:p>
+        </p:txBody>
+      </p:sp>
+      <p:sp>
+        <p:nvSpPr>
+          <p:cNvPr id="5" name="Rectangle 4"/>
+          <p:cNvSpPr/>
+          <p:nvPr/>
+        </p:nvSpPr>
+        <p:spPr>
+          <a:xfrm>
+            <a:off x="5486400" y="1371600"/>
+            <a:ext cx="3200400" cy="4572000"/>
+          </a:xfrm>
+          <a:prstGeom prst="rect">
+            <a:avLst/>
+          </a:prstGeom>
+          <a:solidFill>
+            <a:srgbClr val="FFFFFF"/>
+          </a:solidFill>
+          <a:ln w="25400">
+            <a:solidFill>
+              <a:srgbClr val="ED1C24"/>
+            </a:solidFill>
+          </a:ln>
+        </p:spPr>
+        <p:style>
+          <a:lnRef idx="1">
+            <a:schemeClr val="accent1"/>
+          </a:lnRef>
+          <a:fillRef idx="3">
+            <a:schemeClr val="accent1"/>
+          </a:fillRef>
+          <a:effectRef idx="2">
+            <a:schemeClr val="accent1"/>
+          </a:effectRef>
+          <a:fontRef idx="minor">
+            <a:schemeClr val="lt1"/>
+          </a:fontRef>
+        </p:style>
+        <p:txBody>
+          <a:bodyPr rtlCol="0" anchor="ctr"/>
+          <a:lstStyle/>
+          <a:p>
+            <a:pPr algn="ctr">
+              <a:defRPr sz="1200" b="0">
+                <a:solidFill>
+                  <a:srgbClr val="282828"/>
+                </a:solidFill>
+                <a:latin typeface="Calibri"/>
+              </a:defRPr>
+            </a:pPr>
+            <a:r>
+              <a:t>[VISUEL KADEA]</a:t>
+            </a:r>
+            <a:br/>
+            <a:r>
+              <a:t>Infographie montrant le concept visuel de la Projection (colonnes verticales en surbrillance) et de la Sélection (lignes horizontales en surbrillance).</a:t>
             </a:r>
           </a:p>
         </p:txBody>
@@ -5905,4 +7538,324 @@
   </a:objectDefaults>
   <a:extraClrSchemeLst/>
 </a:theme>
+</file>
+
+<file path=ppt/theme/theme2.xml><?xml version="1.0" encoding="utf-8"?>
+<a:theme xmlns:a="http://schemas.openxmlformats.org/drawingml/2006/main" name="Office Theme">
+  <a:themeElements>
+    <a:clrScheme name="Office">
+      <a:dk1>
+        <a:sysClr val="windowText" lastClr="000000"/>
+      </a:dk1>
+      <a:lt1>
+        <a:sysClr val="window" lastClr="FFFFFF"/>
+      </a:lt1>
+      <a:dk2>
+        <a:srgbClr val="1F497D"/>
+      </a:dk2>
+      <a:lt2>
+        <a:srgbClr val="EEECE1"/>
+      </a:lt2>
+      <a:accent1>
+        <a:srgbClr val="4F81BD"/>
+      </a:accent1>
+      <a:accent2>
+        <a:srgbClr val="C0504D"/>
+      </a:accent2>
+      <a:accent3>
+        <a:srgbClr val="9BBB59"/>
+      </a:accent3>
+      <a:accent4>
+        <a:srgbClr val="8064A2"/>
+      </a:accent4>
+      <a:accent5>
+        <a:srgbClr val="4BACC6"/>
+      </a:accent5>
+      <a:accent6>
+        <a:srgbClr val="F79646"/>
+      </a:accent6>
+      <a:hlink>
+        <a:srgbClr val="0000FF"/>
+      </a:hlink>
+      <a:folHlink>
+        <a:srgbClr val="800080"/>
+      </a:folHlink>
+    </a:clrScheme>
+    <a:fontScheme name="Office">
+      <a:majorFont>
+        <a:latin typeface="Calibri"/>
+        <a:ea typeface=""/>
+        <a:cs typeface=""/>
+        <a:font script="Jpan" typeface="ＭＳ Ｐゴシック"/>
+        <a:font script="Hang" typeface="맑은 고딕"/>
+        <a:font script="Hans" typeface="宋体"/>
+        <a:font script="Hant" typeface="新細明體"/>
+        <a:font script="Arab" typeface="Times New Roman"/>
+        <a:font script="Hebr" typeface="Times New Roman"/>
+        <a:font script="Thai" typeface="Angsana New"/>
+        <a:font script="Ethi" typeface="Nyala"/>
+        <a:font script="Beng" typeface="Vrinda"/>
+        <a:font script="Gujr" typeface="Shruti"/>
+        <a:font script="Khmr" typeface="MoolBoran"/>
+        <a:font script="Knda" typeface="Tunga"/>
+        <a:font script="Guru" typeface="Raavi"/>
+        <a:font script="Cans" typeface="Euphemia"/>
+        <a:font script="Cher" typeface="Plantagenet Cherokee"/>
+        <a:font script="Yiii" typeface="Microsoft Yi Baiti"/>
+        <a:font script="Tibt" typeface="Microsoft Himalaya"/>
+        <a:font script="Thaa" typeface="MV Boli"/>
+        <a:font script="Deva" typeface="Mangal"/>
+        <a:font script="Telu" typeface="Gautami"/>
+        <a:font script="Taml" typeface="Latha"/>
+        <a:font script="Syrc" typeface="Estrangelo Edessa"/>
+        <a:font script="Orya" typeface="Kalinga"/>
+        <a:font script="Mlym" typeface="Kartika"/>
+        <a:font script="Laoo" typeface="DokChampa"/>
+        <a:font script="Sinh" typeface="Iskoola Pota"/>
+        <a:font script="Mong" typeface="Mongolian Baiti"/>
+        <a:font script="Viet" typeface="Times New Roman"/>
+        <a:font script="Uigh" typeface="Microsoft Uighur"/>
+        <a:font script="Geor" typeface="Sylfaen"/>
+      </a:majorFont>
+      <a:minorFont>
+        <a:latin typeface="Calibri"/>
+        <a:ea typeface=""/>
+        <a:cs typeface=""/>
+        <a:font script="Jpan" typeface="ＭＳ Ｐゴシック"/>
+        <a:font script="Hang" typeface="맑은 고딕"/>
+        <a:font script="Hans" typeface="宋体"/>
+        <a:font script="Hant" typeface="新細明體"/>
+        <a:font script="Arab" typeface="Arial"/>
+        <a:font script="Hebr" typeface="Arial"/>
+        <a:font script="Thai" typeface="Cordia New"/>
+        <a:font script="Ethi" typeface="Nyala"/>
+        <a:font script="Beng" typeface="Vrinda"/>
+        <a:font script="Gujr" typeface="Shruti"/>
+        <a:font script="Khmr" typeface="DaunPenh"/>
+        <a:font script="Knda" typeface="Tunga"/>
+        <a:font script="Guru" typeface="Raavi"/>
+        <a:font script="Cans" typeface="Euphemia"/>
+        <a:font script="Cher" typeface="Plantagenet Cherokee"/>
+        <a:font script="Yiii" typeface="Microsoft Yi Baiti"/>
+        <a:font script="Tibt" typeface="Microsoft Himalaya"/>
+        <a:font script="Thaa" typeface="MV Boli"/>
+        <a:font script="Deva" typeface="Mangal"/>
+        <a:font script="Telu" typeface="Gautami"/>
+        <a:font script="Taml" typeface="Latha"/>
+        <a:font script="Syrc" typeface="Estrangelo Edessa"/>
+        <a:font script="Orya" typeface="Kalinga"/>
+        <a:font script="Mlym" typeface="Kartika"/>
+        <a:font script="Laoo" typeface="DokChampa"/>
+        <a:font script="Sinh" typeface="Iskoola Pota"/>
+        <a:font script="Mong" typeface="Mongolian Baiti"/>
+        <a:font script="Viet" typeface="Arial"/>
+        <a:font script="Uigh" typeface="Microsoft Uighur"/>
+        <a:font script="Geor" typeface="Sylfaen"/>
+      </a:minorFont>
+    </a:fontScheme>
+    <a:fmtScheme name="Office">
+      <a:fillStyleLst>
+        <a:solidFill>
+          <a:schemeClr val="phClr"/>
+        </a:solidFill>
+        <a:gradFill rotWithShape="1">
+          <a:gsLst>
+            <a:gs pos="0">
+              <a:schemeClr val="phClr">
+                <a:tint val="50000"/>
+                <a:satMod val="300000"/>
+              </a:schemeClr>
+            </a:gs>
+            <a:gs pos="35000">
+              <a:schemeClr val="phClr">
+                <a:tint val="37000"/>
+                <a:satMod val="300000"/>
+              </a:schemeClr>
+            </a:gs>
+            <a:gs pos="100000">
+              <a:schemeClr val="phClr">
+                <a:tint val="15000"/>
+                <a:satMod val="350000"/>
+              </a:schemeClr>
+            </a:gs>
+          </a:gsLst>
+          <a:lin ang="16200000" scaled="1"/>
+        </a:gradFill>
+        <a:gradFill rotWithShape="1">
+          <a:gsLst>
+            <a:gs pos="0">
+              <a:schemeClr val="phClr">
+                <a:tint val="100000"/>
+                <a:shade val="100000"/>
+                <a:satMod val="130000"/>
+              </a:schemeClr>
+            </a:gs>
+            <a:gs pos="100000">
+              <a:schemeClr val="phClr">
+                <a:tint val="50000"/>
+                <a:shade val="100000"/>
+                <a:satMod val="350000"/>
+              </a:schemeClr>
+            </a:gs>
+          </a:gsLst>
+          <a:lin ang="16200000" scaled="0"/>
+        </a:gradFill>
+      </a:fillStyleLst>
+      <a:lnStyleLst>
+        <a:ln w="9525" cap="flat" cmpd="sng" algn="ctr">
+          <a:solidFill>
+            <a:schemeClr val="phClr">
+              <a:shade val="95000"/>
+              <a:satMod val="105000"/>
+            </a:schemeClr>
+          </a:solidFill>
+          <a:prstDash val="solid"/>
+        </a:ln>
+        <a:ln w="25400" cap="flat" cmpd="sng" algn="ctr">
+          <a:solidFill>
+            <a:schemeClr val="phClr"/>
+          </a:solidFill>
+          <a:prstDash val="solid"/>
+        </a:ln>
+        <a:ln w="38100" cap="flat" cmpd="sng" algn="ctr">
+          <a:solidFill>
+            <a:schemeClr val="phClr"/>
+          </a:solidFill>
+          <a:prstDash val="solid"/>
+        </a:ln>
+      </a:lnStyleLst>
+      <a:effectStyleLst>
+        <a:effectStyle>
+          <a:effectLst>
+            <a:outerShdw blurRad="40000" dist="20000" dir="5400000" rotWithShape="0">
+              <a:srgbClr val="000000">
+                <a:alpha val="38000"/>
+              </a:srgbClr>
+            </a:outerShdw>
+          </a:effectLst>
+        </a:effectStyle>
+        <a:effectStyle>
+          <a:effectLst>
+            <a:outerShdw blurRad="40000" dist="23000" dir="5400000" rotWithShape="0">
+              <a:srgbClr val="000000">
+                <a:alpha val="35000"/>
+              </a:srgbClr>
+            </a:outerShdw>
+          </a:effectLst>
+        </a:effectStyle>
+        <a:effectStyle>
+          <a:effectLst>
+            <a:outerShdw blurRad="40000" dist="23000" dir="5400000" rotWithShape="0">
+              <a:srgbClr val="000000">
+                <a:alpha val="35000"/>
+              </a:srgbClr>
+            </a:outerShdw>
+          </a:effectLst>
+          <a:scene3d>
+            <a:camera prst="orthographicFront">
+              <a:rot lat="0" lon="0" rev="0"/>
+            </a:camera>
+            <a:lightRig rig="threePt" dir="t">
+              <a:rot lat="0" lon="0" rev="1200000"/>
+            </a:lightRig>
+          </a:scene3d>
+          <a:sp3d>
+            <a:bevelT w="63500" h="25400"/>
+          </a:sp3d>
+        </a:effectStyle>
+      </a:effectStyleLst>
+      <a:bgFillStyleLst>
+        <a:solidFill>
+          <a:schemeClr val="phClr"/>
+        </a:solidFill>
+        <a:gradFill rotWithShape="1">
+          <a:gsLst>
+            <a:gs pos="0">
+              <a:schemeClr val="phClr">
+                <a:tint val="40000"/>
+                <a:satMod val="350000"/>
+              </a:schemeClr>
+            </a:gs>
+            <a:gs pos="40000">
+              <a:schemeClr val="phClr">
+                <a:tint val="45000"/>
+                <a:shade val="99000"/>
+                <a:satMod val="350000"/>
+              </a:schemeClr>
+            </a:gs>
+            <a:gs pos="100000">
+              <a:schemeClr val="phClr">
+                <a:shade val="20000"/>
+                <a:satMod val="255000"/>
+              </a:schemeClr>
+            </a:gs>
+          </a:gsLst>
+          <a:path path="circle">
+            <a:fillToRect l="50000" t="-80000" r="50000" b="180000"/>
+          </a:path>
+        </a:gradFill>
+        <a:gradFill rotWithShape="1">
+          <a:gsLst>
+            <a:gs pos="0">
+              <a:schemeClr val="phClr">
+                <a:tint val="80000"/>
+                <a:satMod val="300000"/>
+              </a:schemeClr>
+            </a:gs>
+            <a:gs pos="100000">
+              <a:schemeClr val="phClr">
+                <a:shade val="30000"/>
+                <a:satMod val="200000"/>
+              </a:schemeClr>
+            </a:gs>
+          </a:gsLst>
+          <a:path path="circle">
+            <a:fillToRect l="50000" t="50000" r="50000" b="50000"/>
+          </a:path>
+        </a:gradFill>
+      </a:bgFillStyleLst>
+    </a:fmtScheme>
+  </a:themeElements>
+  <a:objectDefaults>
+    <a:spDef>
+      <a:spPr/>
+      <a:bodyPr/>
+      <a:lstStyle/>
+      <a:style>
+        <a:lnRef idx="1">
+          <a:schemeClr val="accent1"/>
+        </a:lnRef>
+        <a:fillRef idx="3">
+          <a:schemeClr val="accent1"/>
+        </a:fillRef>
+        <a:effectRef idx="2">
+          <a:schemeClr val="accent1"/>
+        </a:effectRef>
+        <a:fontRef idx="minor">
+          <a:schemeClr val="lt1"/>
+        </a:fontRef>
+      </a:style>
+    </a:spDef>
+    <a:lnDef>
+      <a:spPr/>
+      <a:bodyPr/>
+      <a:lstStyle/>
+      <a:style>
+        <a:lnRef idx="2">
+          <a:schemeClr val="accent1"/>
+        </a:lnRef>
+        <a:fillRef idx="0">
+          <a:schemeClr val="accent1"/>
+        </a:fillRef>
+        <a:effectRef idx="1">
+          <a:schemeClr val="accent1"/>
+        </a:effectRef>
+        <a:fontRef idx="minor">
+          <a:schemeClr val="tx1"/>
+        </a:fontRef>
+      </a:style>
+    </a:lnDef>
+  </a:objectDefaults>
+  <a:extraClrSchemeLst/>
+</a:theme>
 </file>
</xml_diff>